<commit_message>
Evaluate frozen procedure on two new subjects and update submission materials
</commit_message>
<xml_diff>
--- a/docs/presentation.pptx
+++ b/docs/presentation.pptx
@@ -2,19 +2,19 @@
 <file path=ppt/presentation.xml><?xml version="1.0" encoding="utf-8"?>
 <p:presentation xmlns:p="http://schemas.openxmlformats.org/presentationml/2006/main">
   <p:sldMasterIdLst>
-    <p:sldMasterId xmlns:r="http://schemas.openxmlformats.org/officeDocument/2006/relationships" id="2147483648" r:id="R46486430693340c3"/>
+    <p:sldMasterId xmlns:r="http://schemas.openxmlformats.org/officeDocument/2006/relationships" id="2147483648" r:id="R84fdd201ff704365"/>
   </p:sldMasterIdLst>
   <p:notesMasterIdLst>
-    <p:notesMasterId xmlns:r="http://schemas.openxmlformats.org/officeDocument/2006/relationships" r:id="R0709b79c3f5b4975"/>
+    <p:notesMasterId xmlns:r="http://schemas.openxmlformats.org/officeDocument/2006/relationships" r:id="Ra3a6f4d71ef440eb"/>
   </p:notesMasterIdLst>
   <p:sldIdLst>
-    <p:sldId xmlns:r="http://schemas.openxmlformats.org/officeDocument/2006/relationships" id="256" r:id="R7a55c5988c594c70"/>
-    <p:sldId xmlns:r="http://schemas.openxmlformats.org/officeDocument/2006/relationships" id="257" r:id="R21fbb7d7f1a3470f"/>
-    <p:sldId xmlns:r="http://schemas.openxmlformats.org/officeDocument/2006/relationships" id="258" r:id="R9f5c841de0044f34"/>
-    <p:sldId xmlns:r="http://schemas.openxmlformats.org/officeDocument/2006/relationships" id="259" r:id="R5187ccf108de4b76"/>
-    <p:sldId xmlns:r="http://schemas.openxmlformats.org/officeDocument/2006/relationships" id="260" r:id="R72c49f5a107d40ca"/>
-    <p:sldId xmlns:r="http://schemas.openxmlformats.org/officeDocument/2006/relationships" id="261" r:id="Rcacf905f8d944901"/>
-    <p:sldId xmlns:r="http://schemas.openxmlformats.org/officeDocument/2006/relationships" id="262" r:id="R5830468756824b5b"/>
+    <p:sldId xmlns:r="http://schemas.openxmlformats.org/officeDocument/2006/relationships" id="256" r:id="Rba1fb74678734ffb"/>
+    <p:sldId xmlns:r="http://schemas.openxmlformats.org/officeDocument/2006/relationships" id="257" r:id="Ra484f25ed4294b81"/>
+    <p:sldId xmlns:r="http://schemas.openxmlformats.org/officeDocument/2006/relationships" id="258" r:id="Re11ee7c5bcca4c76"/>
+    <p:sldId xmlns:r="http://schemas.openxmlformats.org/officeDocument/2006/relationships" id="259" r:id="R6af774eb01154b88"/>
+    <p:sldId xmlns:r="http://schemas.openxmlformats.org/officeDocument/2006/relationships" id="260" r:id="Rb1af8218a8ec4c18"/>
+    <p:sldId xmlns:r="http://schemas.openxmlformats.org/officeDocument/2006/relationships" id="261" r:id="R7be79585531149d6"/>
+    <p:sldId xmlns:r="http://schemas.openxmlformats.org/officeDocument/2006/relationships" id="262" r:id="Rfeadd92420984ad4"/>
   </p:sldIdLst>
   <p:sldSz cx="12192000" cy="6858000"/>
   <p:notesSz cx="6858000" cy="9144000"/>
@@ -448,7 +448,7 @@
           <a:lstStyle xmlns:a="http://schemas.openxmlformats.org/drawingml/2006/main"/>
           <a:p xmlns:a="http://schemas.openxmlformats.org/drawingml/2006/main">
             <a:r>
-              <a:t>Концепция и первый программный эксперимент. Аппаратная кисть не подключалась. Источник задания: https://kids.sk.ru/skkidschallenge</a:t>
+              <a:t>Проверяется компромисс ошибок, отказов и задержки. Это программный прототип; кисть не подключена. Ограничение полной реакции 100 мс пока не подтверждено.</a:t>
             </a:r>
           </a:p>
         </p:txBody>
@@ -518,7 +518,7 @@
           <a:lstStyle xmlns:a="http://schemas.openxmlformats.org/drawingml/2006/main"/>
           <a:p xmlns:a="http://schemas.openxmlformats.org/drawingml/2006/main">
             <a:r>
-              <a:t>Данные: https://ninapro.hevs.ch/instructions/DB2.html . Соответствие хватов: https://ninapro.hevs.ch/figures/SData_Movements.png . Использованы первые восемь каналов из двенадцати. Один участник без ампутации; результаты нельзя переносить на пациентов.</a:t>
+              <a:t>Источник данных: https://ninapro.hevs.ch/instructions/DB2.html ; таблица движений: https://ninapro.hevs.ch/figures/SData_Movements.png . Первые восемь каналов. Все участники без ампутации. На каждого приходится 30 выбранных фрагментов: пять движений по шесть повторов. Включено до 0,5 с соседнего покоя.</a:t>
             </a:r>
           </a:p>
         </p:txBody>
@@ -588,7 +588,7 @@
           <a:lstStyle xmlns:a="http://schemas.openxmlformats.org/drawingml/2006/main"/>
           <a:p xmlns:a="http://schemas.openxmlformats.org/drawingml/2006/main">
             <a:r>
-              <a:t>Блок-схема создана как редактируемые объекты. Фильтр 20–450 Гц и notch 50 Гц, шаг 10 мс. RMS + MAV, WL, ZC, SSC по восьми каналам. Проверка качества сигнала: постоянный канал и чрезмерный разброс. Привод обязан явно обрабатывать inhibit; молчание не равно остановке.</a:t>
+              <a:t>Реализован участок от цифрового сигнала до команды. Фильтр 20–450 Гц и notch 50 Гц, только прошлые отсчёты. RMS, MAV, WL, ZC, SSC. В SVM — логарифмирование, окно 100 мс; LDA — исходные признаки, окно 150 мс. Оценки калибруются внутри train по повторам. Покой не означает раскрытие кисти.</a:t>
             </a:r>
           </a:p>
         </p:txBody>
@@ -658,7 +658,7 @@
           <a:lstStyle xmlns:a="http://schemas.openxmlformats.org/drawingml/2006/main"/>
           <a:p xmlns:a="http://schemas.openxmlformats.org/drawingml/2006/main">
             <a:r>
-              <a:t>Источник: results/db2_s1/metrics.json. Данные: S1_E2_A1.mat. Калибровка sigmoid внутри обучающих повторений с GroupKFold(3). Нормировка обучается внутри каждого фолда. Тестовые переходы сохранены. Это не независимые пациенты или разные дни.</a:t>
+              <a:t>Протокол и конфигурации: коммит fe22ce7, docs/protocol-v2.md. Выбирается macro-F1 на валидации S1. Окна 50,75,100,150 мс; td/log_td; LDA и SVM C=1/10. Сравнение старой и новой версии на совпадающих временных точках: results/study/paired_comparison.json. Вклад отдельных правок не изолирован.</a:t>
             </a:r>
           </a:p>
         </p:txBody>
@@ -728,7 +728,7 @@
           <a:lstStyle xmlns:a="http://schemas.openxmlformats.org/drawingml/2006/main"/>
           <a:p xmlns:a="http://schemas.openxmlformats.org/drawingml/2006/main">
             <a:r>
-              <a:t>Источник: results/db2_s1/metrics.json и CSV. Порог SVM 0,5; три подтверждения. Параметры выбраны по валидации. Отказ не считается сменой хвата. Ошибочное переключение — изменение принятого класса на класс, не совпадающий с текущей меткой. Это программные события, а не число движений реального привода.</a:t>
+              <a:t>Для S2 выбраны три подтверждения без порога. S3: threshold=0.5, margin=0.15, confirmations=2. Валидационное покрытие S3 70,96%, тестовое 67,84%. На обоих участниках получена правильная команда в каждом из десяти движений, но ранний правильный кадр не равен устойчивому управлению. Ошибочное переключение — смена принятого класса на неверный.</a:t>
             </a:r>
           </a:p>
         </p:txBody>
@@ -798,7 +798,7 @@
           <a:lstStyle xmlns:a="http://schemas.openxmlformats.org/drawingml/2006/main"/>
           <a:p xmlns:a="http://schemas.openxmlformats.org/drawingml/2006/main">
             <a:r>
-              <a:t>Источник: results/db2_s1/metrics.json. Измерения Python на macOS arm64, не STM32. Пропуски представлены отдельно. Длина окна 50 мс и шаг 10 мс сами по себе не доказывают задержку 100 мс. Исследование компромисса окна и задержки: https://pmc.ncbi.nlm.nih.gov/articles/PMC4241762/</a:t>
+              <a:t>Отсчёт по restimulus, не по независимому измерению сокращения. Нулевая медиана первого ответа S2 не является мгновенной физической реакцией. Сбор информативного участка 40 + шаг10 + задержка тракта5 + признаки1 + модель3 + подтверждение10 + связь3 + движение20 =92 мс. Это лимиты проектирования, не измеренные показатели. Выбранные окна 100/150 мс не подтверждают выполнение ТЗ. Подробнее: отчёт, страницы 5–6.</a:t>
             </a:r>
           </a:p>
         </p:txBody>
@@ -868,7 +868,7 @@
           <a:lstStyle xmlns:a="http://schemas.openxmlformats.org/drawingml/2006/main"/>
           <a:p xmlns:a="http://schemas.openxmlformats.org/drawingml/2006/main">
             <a:r>
-              <a:t>Бюджет является собственной проектной оценкой, не котировками поставщиков. ADS1298: https://www.ti.com/product/ADS1298 . STM32H743: https://www.st.com/en/microcontrollers-microprocessors/stm32h743-753.html . Отказ от ненадёжных решений уже исследуется: https://arxiv.org/abs/2409.14169 . Новизна мирового уровня не заявляется.</a:t>
+              <a:t>Съём ADS1298, вычислитель STM32H743: https://www.ti.com/product/ADS1298 ; https://www.st.com/en/microcontrollers-microprocessors/stm32h743-753.html . Резерв до 200000 руб. —40000. Нужна лаборатория; зарплата и клинические испытания не включены. docs/demo.html воспроизводит сохранённые результаты; не запускает модель и не управляет кистью. Само отклонение решений не заявляется новой идеей: https://arxiv.org/abs/2409.14169 .</a:t>
             </a:r>
           </a:p>
         </p:txBody>
@@ -936,7 +936,7 @@
   </p:cSld>
   <p:clrMap bg1="lt1" tx1="dk1" bg2="lt2" tx2="dk2" accent1="accent1" accent2="accent2" accent3="accent3" accent4="accent4" accent5="accent5" accent6="accent6" hlink="hlink" folHlink="folHlink"/>
   <p:sldLayoutIdLst>
-    <p:sldLayoutId xmlns:r="http://schemas.openxmlformats.org/officeDocument/2006/relationships" id="2147483649" r:id="R7ed2b979cda94a61"/>
+    <p:sldLayoutId xmlns:r="http://schemas.openxmlformats.org/officeDocument/2006/relationships" id="2147483649" r:id="Re32a0fd918524ce3"/>
   </p:sldLayoutIdLst>
   <p:txStyles>
     <p:titleStyle>
@@ -1487,7 +1487,7 @@
           <p:cNvPr id="6" name="">
             <a:extLst xmlns:a="http://schemas.openxmlformats.org/drawingml/2006/main">
               <a:ext uri="{FF2B5EF4-FFF2-40B4-BE49-F238E27FC236}">
-                <a16:creationId xmlns:a16="http://schemas.microsoft.com/office/drawing/2014/main" id="{8D0A2D3D-47EE-4831-9A3B-C1E7B029694B}"/>
+                <a16:creationId xmlns:a16="http://schemas.microsoft.com/office/drawing/2014/main" id="{84D92C3E-7B5E-4E59-936F-74EACBB48D9B}"/>
               </a:ext>
             </a:extLst>
           </p:cNvPr>
@@ -1544,7 +1544,7 @@
           <p:cNvPr id="2" name="">
             <a:extLst xmlns:a="http://schemas.openxmlformats.org/drawingml/2006/main">
               <a:ext uri="{FF2B5EF4-FFF2-40B4-BE49-F238E27FC236}">
-                <a16:creationId xmlns:a16="http://schemas.microsoft.com/office/drawing/2014/main" id="{74CC139D-4349-4B61-BDB6-2B1C84C2548E}"/>
+                <a16:creationId xmlns:a16="http://schemas.microsoft.com/office/drawing/2014/main" id="{B64D6E9E-A41A-44C5-808F-16EAA7E0071B}"/>
               </a:ext>
             </a:extLst>
           </p:cNvPr>
@@ -1601,7 +1601,7 @@
           <p:cNvPr id="3" name="">
             <a:extLst xmlns:a="http://schemas.openxmlformats.org/drawingml/2006/main">
               <a:ext uri="{FF2B5EF4-FFF2-40B4-BE49-F238E27FC236}">
-                <a16:creationId xmlns:a16="http://schemas.microsoft.com/office/drawing/2014/main" id="{57F711FD-6CE9-42A9-A642-803FC0C2962E}"/>
+                <a16:creationId xmlns:a16="http://schemas.microsoft.com/office/drawing/2014/main" id="{0296FE3A-2C8C-4182-ACF3-F46B432B0098}"/>
               </a:ext>
             </a:extLst>
           </p:cNvPr>
@@ -1612,8 +1612,8 @@
         </p:nvSpPr>
         <p:spPr>
           <a:xfrm xmlns:a="http://schemas.openxmlformats.org/drawingml/2006/main">
-            <a:off x="609600" y="1857375"/>
-            <a:ext cx="10287000" cy="1238250"/>
+            <a:off x="609600" y="1714500"/>
+            <a:ext cx="10572750" cy="1285875"/>
           </a:xfrm>
           <a:prstGeom xmlns:a="http://schemas.openxmlformats.org/drawingml/2006/main" prst="rect">
             <a:avLst/>
@@ -1630,48 +1630,48 @@
           <a:lstStyle xmlns:a="http://schemas.openxmlformats.org/drawingml/2006/main"/>
           <a:p xmlns:a="http://schemas.openxmlformats.org/drawingml/2006/main">
             <a:pPr>
-              <a:defRPr sz="3300" b="0">
-                <a:solidFill>
-                  <a:srgbClr val="232A25"/>
-                </a:solidFill>
-                <a:latin typeface="Arial"/>
-                <a:ea typeface="Arial"/>
-                <a:cs typeface="Arial"/>
-              </a:defRPr>
-            </a:pPr>
-            <a:r>
-              <a:rPr sz="3300" b="0">
-                <a:solidFill>
-                  <a:srgbClr val="232A25"/>
-                </a:solidFill>
-                <a:latin typeface="Arial"/>
-                <a:ea typeface="Arial"/>
-                <a:cs typeface="Arial"/>
-              </a:rPr>
-              <a:t>Проверка команд при распознавании</a:t>
-            </a:r>
-          </a:p>
-          <a:p xmlns:a="http://schemas.openxmlformats.org/drawingml/2006/main">
-            <a:pPr>
-              <a:defRPr sz="3300" b="0">
-                <a:solidFill>
-                  <a:srgbClr val="232A25"/>
-                </a:solidFill>
-                <a:latin typeface="Arial"/>
-                <a:ea typeface="Arial"/>
-                <a:cs typeface="Arial"/>
-              </a:defRPr>
-            </a:pPr>
-            <a:r>
-              <a:rPr sz="3300" b="0">
-                <a:solidFill>
-                  <a:srgbClr val="232A25"/>
-                </a:solidFill>
-                <a:latin typeface="Arial"/>
-                <a:ea typeface="Arial"/>
-                <a:cs typeface="Arial"/>
-              </a:rPr>
-              <a:t>хватов по поверхностной ЭМГ</a:t>
+              <a:defRPr sz="3525" b="1">
+                <a:solidFill>
+                  <a:srgbClr val="232A25"/>
+                </a:solidFill>
+                <a:latin typeface="Arial"/>
+                <a:ea typeface="Arial"/>
+                <a:cs typeface="Arial"/>
+              </a:defRPr>
+            </a:pPr>
+            <a:r>
+              <a:rPr sz="3525" b="1">
+                <a:solidFill>
+                  <a:srgbClr val="232A25"/>
+                </a:solidFill>
+                <a:latin typeface="Arial"/>
+                <a:ea typeface="Arial"/>
+                <a:cs typeface="Arial"/>
+              </a:rPr>
+              <a:t>Как не менять хват</a:t>
+            </a:r>
+          </a:p>
+          <a:p xmlns:a="http://schemas.openxmlformats.org/drawingml/2006/main">
+            <a:pPr>
+              <a:defRPr sz="3525" b="1">
+                <a:solidFill>
+                  <a:srgbClr val="232A25"/>
+                </a:solidFill>
+                <a:latin typeface="Arial"/>
+                <a:ea typeface="Arial"/>
+                <a:cs typeface="Arial"/>
+              </a:defRPr>
+            </a:pPr>
+            <a:r>
+              <a:rPr sz="3525" b="1">
+                <a:solidFill>
+                  <a:srgbClr val="232A25"/>
+                </a:solidFill>
+                <a:latin typeface="Arial"/>
+                <a:ea typeface="Arial"/>
+                <a:cs typeface="Arial"/>
+              </a:rPr>
+              <a:t>из-за сомнительной команды</a:t>
             </a:r>
           </a:p>
         </p:txBody>
@@ -1681,7 +1681,7 @@
           <p:cNvPr id="4" name="">
             <a:extLst xmlns:a="http://schemas.openxmlformats.org/drawingml/2006/main">
               <a:ext uri="{FF2B5EF4-FFF2-40B4-BE49-F238E27FC236}">
-                <a16:creationId xmlns:a16="http://schemas.microsoft.com/office/drawing/2014/main" id="{BDF2DA14-D4CF-4AB2-965C-632C1355458E}"/>
+                <a16:creationId xmlns:a16="http://schemas.microsoft.com/office/drawing/2014/main" id="{9A5F7EDB-7104-4283-93B8-85272573D15D}"/>
               </a:ext>
             </a:extLst>
           </p:cNvPr>
@@ -1692,8 +1692,8 @@
         </p:nvSpPr>
         <p:spPr>
           <a:xfrm xmlns:a="http://schemas.openxmlformats.org/drawingml/2006/main">
-            <a:off x="609600" y="3762375"/>
-            <a:ext cx="10382250" cy="762000"/>
+            <a:off x="609600" y="3476625"/>
+            <a:ext cx="10477500" cy="1095375"/>
           </a:xfrm>
           <a:prstGeom xmlns:a="http://schemas.openxmlformats.org/drawingml/2006/main" prst="rect">
             <a:avLst/>
@@ -1710,7 +1710,7 @@
           <a:lstStyle xmlns:a="http://schemas.openxmlformats.org/drawingml/2006/main"/>
           <a:p xmlns:a="http://schemas.openxmlformats.org/drawingml/2006/main">
             <a:pPr>
-              <a:defRPr sz="2100" b="0">
+              <a:defRPr sz="2250" b="0">
                 <a:solidFill>
                   <a:srgbClr val="59635B"/>
                 </a:solidFill>
@@ -1720,7 +1720,7 @@
               </a:defRPr>
             </a:pPr>
             <a:r>
-              <a:rPr sz="2100" b="0">
+              <a:rPr sz="2250" b="0">
                 <a:solidFill>
                   <a:srgbClr val="59635B"/>
                 </a:solidFill>
@@ -1728,7 +1728,30 @@
                 <a:ea typeface="Arial"/>
                 <a:cs typeface="Arial"/>
               </a:rPr>
-              <a:t>Пять хватов и покой. Первый опыт на реальных данных NinaPro.</a:t>
+              <a:t>Пять хватов и покой по поверхностной ЭМГ.</a:t>
+            </a:r>
+          </a:p>
+          <a:p xmlns:a="http://schemas.openxmlformats.org/drawingml/2006/main">
+            <a:pPr>
+              <a:defRPr sz="2250" b="0">
+                <a:solidFill>
+                  <a:srgbClr val="59635B"/>
+                </a:solidFill>
+                <a:latin typeface="Arial"/>
+                <a:ea typeface="Arial"/>
+                <a:cs typeface="Arial"/>
+              </a:defRPr>
+            </a:pPr>
+            <a:r>
+              <a:rPr sz="2250" b="0">
+                <a:solidFill>
+                  <a:srgbClr val="59635B"/>
+                </a:solidFill>
+                <a:latin typeface="Arial"/>
+                <a:ea typeface="Arial"/>
+                <a:cs typeface="Arial"/>
+              </a:rPr>
+              <a:t>Программный прототип и проверка на новых записях.</a:t>
             </a:r>
           </a:p>
         </p:txBody>
@@ -1738,7 +1761,7 @@
           <p:cNvPr id="5" name="">
             <a:extLst xmlns:a="http://schemas.openxmlformats.org/drawingml/2006/main">
               <a:ext uri="{FF2B5EF4-FFF2-40B4-BE49-F238E27FC236}">
-                <a16:creationId xmlns:a16="http://schemas.microsoft.com/office/drawing/2014/main" id="{02298FF3-A325-4D0A-A6D5-901E97867ECB}"/>
+                <a16:creationId xmlns:a16="http://schemas.microsoft.com/office/drawing/2014/main" id="{979725A8-FCEF-482A-818A-A888D86FB0C2}"/>
               </a:ext>
             </a:extLst>
           </p:cNvPr>
@@ -1749,8 +1772,8 @@
         </p:nvSpPr>
         <p:spPr>
           <a:xfrm xmlns:a="http://schemas.openxmlformats.org/drawingml/2006/main">
-            <a:off x="609600" y="5381625"/>
-            <a:ext cx="10191750" cy="666750"/>
+            <a:off x="609600" y="5391150"/>
+            <a:ext cx="10477500" cy="723900"/>
           </a:xfrm>
           <a:prstGeom xmlns:a="http://schemas.openxmlformats.org/drawingml/2006/main" prst="rect">
             <a:avLst/>
@@ -1767,7 +1790,7 @@
           <a:lstStyle xmlns:a="http://schemas.openxmlformats.org/drawingml/2006/main"/>
           <a:p xmlns:a="http://schemas.openxmlformats.org/drawingml/2006/main">
             <a:pPr>
-              <a:defRPr sz="1725" b="0">
+              <a:defRPr sz="1800" b="0">
                 <a:solidFill>
                   <a:srgbClr val="59635B"/>
                 </a:solidFill>
@@ -1777,7 +1800,7 @@
               </a:defRPr>
             </a:pPr>
             <a:r>
-              <a:rPr sz="1725" b="0">
+              <a:rPr sz="1800" b="0">
                 <a:solidFill>
                   <a:srgbClr val="59635B"/>
                 </a:solidFill>
@@ -1790,7 +1813,7 @@
           </a:p>
           <a:p xmlns:a="http://schemas.openxmlformats.org/drawingml/2006/main">
             <a:pPr>
-              <a:defRPr sz="1725" b="0">
+              <a:defRPr sz="1800" b="0">
                 <a:solidFill>
                   <a:srgbClr val="59635B"/>
                 </a:solidFill>
@@ -1800,7 +1823,7 @@
               </a:defRPr>
             </a:pPr>
             <a:r>
-              <a:rPr sz="1725" b="0">
+              <a:rPr sz="1800" b="0">
                 <a:solidFill>
                   <a:srgbClr val="59635B"/>
                 </a:solidFill>
@@ -1816,7 +1839,7 @@
     </p:spTree>
     <p:extLst>
       <p:ext uri="{BB962C8B-B14F-4D97-AF65-F5344CB8AC3E}">
-        <p14:creationId xmlns:p14="http://schemas.microsoft.com/office/powerpoint/2010/main" val="1626334067"/>
+        <p14:creationId xmlns:p14="http://schemas.microsoft.com/office/powerpoint/2010/main" val="209110345"/>
       </p:ext>
     </p:extLst>
   </p:cSld>
@@ -1847,7 +1870,7 @@
           <p:cNvPr id="7" name="">
             <a:extLst xmlns:a="http://schemas.openxmlformats.org/drawingml/2006/main">
               <a:ext uri="{FF2B5EF4-FFF2-40B4-BE49-F238E27FC236}">
-                <a16:creationId xmlns:a16="http://schemas.microsoft.com/office/drawing/2014/main" id="{0D53DD7B-BA9B-4E21-8BE6-9E9FA4D5084F}"/>
+                <a16:creationId xmlns:a16="http://schemas.microsoft.com/office/drawing/2014/main" id="{D96B22CE-03B2-4FBD-867F-4FBA74BECB33}"/>
               </a:ext>
             </a:extLst>
           </p:cNvPr>
@@ -1894,7 +1917,7 @@
                 <a:ea typeface="Arial"/>
                 <a:cs typeface="Arial"/>
               </a:rPr>
-              <a:t>Сигнал и выбранные хваты</a:t>
+              <a:t>Что считываем и как проверяем</a:t>
             </a:r>
           </a:p>
         </p:txBody>
@@ -1904,7 +1927,7 @@
           <p:cNvPr id="2" name="">
             <a:extLst xmlns:a="http://schemas.openxmlformats.org/drawingml/2006/main">
               <a:ext uri="{FF2B5EF4-FFF2-40B4-BE49-F238E27FC236}">
-                <a16:creationId xmlns:a16="http://schemas.microsoft.com/office/drawing/2014/main" id="{9F543357-EB47-4C28-A94B-9BBD19CFFC0A}"/>
+                <a16:creationId xmlns:a16="http://schemas.microsoft.com/office/drawing/2014/main" id="{5DD90D25-105E-4030-9922-A465BCF8BBAD}"/>
               </a:ext>
             </a:extLst>
           </p:cNvPr>
@@ -1961,7 +1984,7 @@
           <p:cNvPr id="3" name="">
             <a:extLst xmlns:a="http://schemas.openxmlformats.org/drawingml/2006/main">
               <a:ext uri="{FF2B5EF4-FFF2-40B4-BE49-F238E27FC236}">
-                <a16:creationId xmlns:a16="http://schemas.microsoft.com/office/drawing/2014/main" id="{0239728C-DBB8-4501-94DB-3AB0048D9834}"/>
+                <a16:creationId xmlns:a16="http://schemas.microsoft.com/office/drawing/2014/main" id="{B9057DD1-65C7-48FF-B525-94BC292852A1}"/>
               </a:ext>
             </a:extLst>
           </p:cNvPr>
@@ -1972,8 +1995,8 @@
         </p:nvSpPr>
         <p:spPr>
           <a:xfrm xmlns:a="http://schemas.openxmlformats.org/drawingml/2006/main">
-            <a:off x="609600" y="1257300"/>
-            <a:ext cx="5048250" cy="838200"/>
+            <a:off x="609600" y="1352550"/>
+            <a:ext cx="5095875" cy="904875"/>
           </a:xfrm>
           <a:prstGeom xmlns:a="http://schemas.openxmlformats.org/drawingml/2006/main" prst="rect">
             <a:avLst/>
@@ -1990,17 +2013,17 @@
           <a:lstStyle xmlns:a="http://schemas.openxmlformats.org/drawingml/2006/main"/>
           <a:p xmlns:a="http://schemas.openxmlformats.org/drawingml/2006/main">
             <a:pPr>
-              <a:defRPr sz="2175" b="1">
-                <a:solidFill>
-                  <a:srgbClr val="232A25"/>
-                </a:solidFill>
-                <a:latin typeface="Arial"/>
-                <a:ea typeface="Arial"/>
-                <a:cs typeface="Arial"/>
-              </a:defRPr>
-            </a:pPr>
-            <a:r>
-              <a:rPr sz="2175" b="1">
+              <a:defRPr sz="2400" b="1">
+                <a:solidFill>
+                  <a:srgbClr val="232A25"/>
+                </a:solidFill>
+                <a:latin typeface="Arial"/>
+                <a:ea typeface="Arial"/>
+                <a:cs typeface="Arial"/>
+              </a:defRPr>
+            </a:pPr>
+            <a:r>
+              <a:rPr sz="2400" b="1">
                 <a:solidFill>
                   <a:srgbClr val="232A25"/>
                 </a:solidFill>
@@ -2013,25 +2036,25 @@
           </a:p>
           <a:p xmlns:a="http://schemas.openxmlformats.org/drawingml/2006/main">
             <a:pPr>
-              <a:defRPr sz="2175" b="1">
-                <a:solidFill>
-                  <a:srgbClr val="232A25"/>
-                </a:solidFill>
-                <a:latin typeface="Arial"/>
-                <a:ea typeface="Arial"/>
-                <a:cs typeface="Arial"/>
-              </a:defRPr>
-            </a:pPr>
-            <a:r>
-              <a:rPr sz="2175" b="1">
-                <a:solidFill>
-                  <a:srgbClr val="232A25"/>
-                </a:solidFill>
-                <a:latin typeface="Arial"/>
-                <a:ea typeface="Arial"/>
-                <a:cs typeface="Arial"/>
-              </a:rPr>
-              <a:t>NinaPro DB2, участник S1</a:t>
+              <a:defRPr sz="2400" b="1">
+                <a:solidFill>
+                  <a:srgbClr val="232A25"/>
+                </a:solidFill>
+                <a:latin typeface="Arial"/>
+                <a:ea typeface="Arial"/>
+                <a:cs typeface="Arial"/>
+              </a:defRPr>
+            </a:pPr>
+            <a:r>
+              <a:rPr sz="2400" b="1">
+                <a:solidFill>
+                  <a:srgbClr val="232A25"/>
+                </a:solidFill>
+                <a:latin typeface="Arial"/>
+                <a:ea typeface="Arial"/>
+                <a:cs typeface="Arial"/>
+              </a:rPr>
+              <a:t>NinaPro DB2</a:t>
             </a:r>
           </a:p>
         </p:txBody>
@@ -2041,7 +2064,7 @@
           <p:cNvPr id="4" name="">
             <a:extLst xmlns:a="http://schemas.openxmlformats.org/drawingml/2006/main">
               <a:ext uri="{FF2B5EF4-FFF2-40B4-BE49-F238E27FC236}">
-                <a16:creationId xmlns:a16="http://schemas.microsoft.com/office/drawing/2014/main" id="{0425F2B9-7F97-403B-93BC-EA2584FDD34B}"/>
+                <a16:creationId xmlns:a16="http://schemas.microsoft.com/office/drawing/2014/main" id="{D4BBA4C4-4025-4264-8993-510C18A27F72}"/>
               </a:ext>
             </a:extLst>
           </p:cNvPr>
@@ -2052,8 +2075,8 @@
         </p:nvSpPr>
         <p:spPr>
           <a:xfrm xmlns:a="http://schemas.openxmlformats.org/drawingml/2006/main">
-            <a:off x="609600" y="2476500"/>
-            <a:ext cx="5048250" cy="1524000"/>
+            <a:off x="609600" y="2676525"/>
+            <a:ext cx="5095875" cy="1219200"/>
           </a:xfrm>
           <a:prstGeom xmlns:a="http://schemas.openxmlformats.org/drawingml/2006/main" prst="rect">
             <a:avLst/>
@@ -2070,94 +2093,71 @@
           <a:lstStyle xmlns:a="http://schemas.openxmlformats.org/drawingml/2006/main"/>
           <a:p xmlns:a="http://schemas.openxmlformats.org/drawingml/2006/main">
             <a:pPr>
-              <a:defRPr sz="2025" b="0">
-                <a:solidFill>
-                  <a:srgbClr val="232A25"/>
-                </a:solidFill>
-                <a:latin typeface="Arial"/>
-                <a:ea typeface="Arial"/>
-                <a:cs typeface="Arial"/>
-              </a:defRPr>
-            </a:pPr>
-            <a:r>
-              <a:rPr sz="2025" b="0">
-                <a:solidFill>
-                  <a:srgbClr val="232A25"/>
-                </a:solidFill>
-                <a:latin typeface="Arial"/>
-                <a:ea typeface="Arial"/>
-                <a:cs typeface="Arial"/>
-              </a:rPr>
-              <a:t>Манжета считывает активность</a:t>
-            </a:r>
-          </a:p>
-          <a:p xmlns:a="http://schemas.openxmlformats.org/drawingml/2006/main">
-            <a:pPr>
-              <a:defRPr sz="2025" b="0">
-                <a:solidFill>
-                  <a:srgbClr val="232A25"/>
-                </a:solidFill>
-                <a:latin typeface="Arial"/>
-                <a:ea typeface="Arial"/>
-                <a:cs typeface="Arial"/>
-              </a:defRPr>
-            </a:pPr>
-            <a:r>
-              <a:rPr sz="2025" b="0">
-                <a:solidFill>
-                  <a:srgbClr val="232A25"/>
-                </a:solidFill>
-                <a:latin typeface="Arial"/>
-                <a:ea typeface="Arial"/>
-                <a:cs typeface="Arial"/>
-              </a:rPr>
-              <a:t>сохранившихся мышц. Размещение</a:t>
-            </a:r>
-          </a:p>
-          <a:p xmlns:a="http://schemas.openxmlformats.org/drawingml/2006/main">
-            <a:pPr>
-              <a:defRPr sz="2025" b="0">
-                <a:solidFill>
-                  <a:srgbClr val="232A25"/>
-                </a:solidFill>
-                <a:latin typeface="Arial"/>
-                <a:ea typeface="Arial"/>
-                <a:cs typeface="Arial"/>
-              </a:defRPr>
-            </a:pPr>
-            <a:r>
-              <a:rPr sz="2025" b="0">
-                <a:solidFill>
-                  <a:srgbClr val="232A25"/>
-                </a:solidFill>
-                <a:latin typeface="Arial"/>
-                <a:ea typeface="Arial"/>
-                <a:cs typeface="Arial"/>
-              </a:rPr>
-              <a:t>для пользователя протеза потребуется</a:t>
-            </a:r>
-          </a:p>
-          <a:p xmlns:a="http://schemas.openxmlformats.org/drawingml/2006/main">
-            <a:pPr>
-              <a:defRPr sz="2025" b="0">
-                <a:solidFill>
-                  <a:srgbClr val="232A25"/>
-                </a:solidFill>
-                <a:latin typeface="Arial"/>
-                <a:ea typeface="Arial"/>
-                <a:cs typeface="Arial"/>
-              </a:defRPr>
-            </a:pPr>
-            <a:r>
-              <a:rPr sz="2025" b="0">
-                <a:solidFill>
-                  <a:srgbClr val="232A25"/>
-                </a:solidFill>
-                <a:latin typeface="Arial"/>
-                <a:ea typeface="Arial"/>
-                <a:cs typeface="Arial"/>
-              </a:rPr>
-              <a:t>подбирать отдельно.</a:t>
+              <a:defRPr sz="2175" b="0">
+                <a:solidFill>
+                  <a:srgbClr val="232A25"/>
+                </a:solidFill>
+                <a:latin typeface="Arial"/>
+                <a:ea typeface="Arial"/>
+                <a:cs typeface="Arial"/>
+              </a:defRPr>
+            </a:pPr>
+            <a:r>
+              <a:rPr sz="2175" b="0">
+                <a:solidFill>
+                  <a:srgbClr val="232A25"/>
+                </a:solidFill>
+                <a:latin typeface="Arial"/>
+                <a:ea typeface="Arial"/>
+                <a:cs typeface="Arial"/>
+              </a:rPr>
+              <a:t>S1 — выбор признаков и окна.</a:t>
+            </a:r>
+          </a:p>
+          <a:p xmlns:a="http://schemas.openxmlformats.org/drawingml/2006/main">
+            <a:pPr>
+              <a:defRPr sz="2175" b="0">
+                <a:solidFill>
+                  <a:srgbClr val="232A25"/>
+                </a:solidFill>
+                <a:latin typeface="Arial"/>
+                <a:ea typeface="Arial"/>
+                <a:cs typeface="Arial"/>
+              </a:defRPr>
+            </a:pPr>
+            <a:r>
+              <a:rPr sz="2175" b="0">
+                <a:solidFill>
+                  <a:srgbClr val="232A25"/>
+                </a:solidFill>
+                <a:latin typeface="Arial"/>
+                <a:ea typeface="Arial"/>
+                <a:cs typeface="Arial"/>
+              </a:rPr>
+              <a:t>S2 и S3 — новые участники</a:t>
+            </a:r>
+          </a:p>
+          <a:p xmlns:a="http://schemas.openxmlformats.org/drawingml/2006/main">
+            <a:pPr>
+              <a:defRPr sz="2175" b="0">
+                <a:solidFill>
+                  <a:srgbClr val="232A25"/>
+                </a:solidFill>
+                <a:latin typeface="Arial"/>
+                <a:ea typeface="Arial"/>
+                <a:cs typeface="Arial"/>
+              </a:defRPr>
+            </a:pPr>
+            <a:r>
+              <a:rPr sz="2175" b="0">
+                <a:solidFill>
+                  <a:srgbClr val="232A25"/>
+                </a:solidFill>
+                <a:latin typeface="Arial"/>
+                <a:ea typeface="Arial"/>
+                <a:cs typeface="Arial"/>
+              </a:rPr>
+              <a:t>для проверки процедуры.</a:t>
             </a:r>
           </a:p>
         </p:txBody>
@@ -2167,7 +2167,7 @@
           <p:cNvPr id="5" name="">
             <a:extLst xmlns:a="http://schemas.openxmlformats.org/drawingml/2006/main">
               <a:ext uri="{FF2B5EF4-FFF2-40B4-BE49-F238E27FC236}">
-                <a16:creationId xmlns:a16="http://schemas.microsoft.com/office/drawing/2014/main" id="{A1B7AD1D-D74C-4E10-BE4A-8767C1C2E90B}"/>
+                <a16:creationId xmlns:a16="http://schemas.microsoft.com/office/drawing/2014/main" id="{95BB0951-6D4B-49D9-81F9-A95BA0B880C7}"/>
               </a:ext>
             </a:extLst>
           </p:cNvPr>
@@ -2178,8 +2178,8 @@
         </p:nvSpPr>
         <p:spPr>
           <a:xfrm xmlns:a="http://schemas.openxmlformats.org/drawingml/2006/main">
-            <a:off x="609600" y="4457700"/>
-            <a:ext cx="5048250" cy="1181100"/>
+            <a:off x="609600" y="4524375"/>
+            <a:ext cx="5191125" cy="1257300"/>
           </a:xfrm>
           <a:prstGeom xmlns:a="http://schemas.openxmlformats.org/drawingml/2006/main" prst="rect">
             <a:avLst/>
@@ -2214,7 +2214,7 @@
                 <a:ea typeface="Arial"/>
                 <a:cs typeface="Arial"/>
               </a:rPr>
-              <a:t>30 фрагментов: 5 хватов × 6 повторов.</a:t>
+              <a:t>У каждого своя настройка:</a:t>
             </a:r>
           </a:p>
           <a:p xmlns:a="http://schemas.openxmlformats.org/drawingml/2006/main">
@@ -2237,7 +2237,7 @@
                 <a:ea typeface="Arial"/>
                 <a:cs typeface="Arial"/>
               </a:rPr>
-              <a:t>До и после движения добавлено</a:t>
+              <a:t>train 1, 3, 4 · validation 2 · test 5, 6.</a:t>
             </a:r>
           </a:p>
           <a:p xmlns:a="http://schemas.openxmlformats.org/drawingml/2006/main">
@@ -2260,7 +2260,7 @@
                 <a:ea typeface="Arial"/>
                 <a:cs typeface="Arial"/>
               </a:rPr>
-              <a:t>до 0,5 секунды соседнего покоя.</a:t>
+              <a:t>Это не перенос модели между людьми.</a:t>
             </a:r>
           </a:p>
         </p:txBody>
@@ -2272,8 +2272,8 @@
           <p:nvPr/>
         </p:nvGraphicFramePr>
         <p:xfrm>
-          <a:off xmlns:a="http://schemas.openxmlformats.org/drawingml/2006/main" x="6191250" y="1257300"/>
-          <a:ext xmlns:a="http://schemas.openxmlformats.org/drawingml/2006/main" cx="5381625" cy="4476750"/>
+          <a:off xmlns:a="http://schemas.openxmlformats.org/drawingml/2006/main" x="6191250" y="1343025"/>
+          <a:ext xmlns:a="http://schemas.openxmlformats.org/drawingml/2006/main" cx="5381625" cy="4352925"/>
         </p:xfrm>
         <a:graphic xmlns:a="http://schemas.openxmlformats.org/drawingml/2006/main">
           <a:graphicData uri="http://schemas.openxmlformats.org/drawingml/2006/table">
@@ -2283,7 +2283,7 @@
                 <a:gridCol w="3524250"/>
                 <a:gridCol w="1857375"/>
               </a:tblGrid>
-              <a:tr h="639536">
+              <a:tr h="621846">
                 <a:tc>
                   <a:txBody>
                     <a:bodyPr/>
@@ -2333,7 +2333,7 @@
                   </a:tcPr>
                 </a:tc>
               </a:tr>
-              <a:tr h="639536">
+              <a:tr h="621846">
                 <a:tc>
                   <a:txBody>
                     <a:bodyPr/>
@@ -2383,7 +2383,7 @@
                   </a:tcPr>
                 </a:tc>
               </a:tr>
-              <a:tr h="639536">
+              <a:tr h="621846">
                 <a:tc>
                   <a:txBody>
                     <a:bodyPr/>
@@ -2433,7 +2433,7 @@
                   </a:tcPr>
                 </a:tc>
               </a:tr>
-              <a:tr h="639536">
+              <a:tr h="621846">
                 <a:tc>
                   <a:txBody>
                     <a:bodyPr/>
@@ -2483,7 +2483,7 @@
                   </a:tcPr>
                 </a:tc>
               </a:tr>
-              <a:tr h="639536">
+              <a:tr h="621846">
                 <a:tc>
                   <a:txBody>
                     <a:bodyPr/>
@@ -2533,7 +2533,7 @@
                   </a:tcPr>
                 </a:tc>
               </a:tr>
-              <a:tr h="639536">
+              <a:tr h="621846">
                 <a:tc>
                   <a:txBody>
                     <a:bodyPr/>
@@ -2583,7 +2583,7 @@
                   </a:tcPr>
                 </a:tc>
               </a:tr>
-              <a:tr h="639536">
+              <a:tr h="621846">
                 <a:tc>
                   <a:txBody>
                     <a:bodyPr/>
@@ -2640,7 +2640,7 @@
     </p:spTree>
     <p:extLst>
       <p:ext uri="{BB962C8B-B14F-4D97-AF65-F5344CB8AC3E}">
-        <p14:creationId xmlns:p14="http://schemas.microsoft.com/office/powerpoint/2010/main" val="973184175"/>
+        <p14:creationId xmlns:p14="http://schemas.microsoft.com/office/powerpoint/2010/main" val="2060040443"/>
       </p:ext>
     </p:extLst>
   </p:cSld>
@@ -2671,7 +2671,7 @@
           <p:cNvPr id="34" name="">
             <a:extLst xmlns:a="http://schemas.openxmlformats.org/drawingml/2006/main">
               <a:ext uri="{FF2B5EF4-FFF2-40B4-BE49-F238E27FC236}">
-                <a16:creationId xmlns:a16="http://schemas.microsoft.com/office/drawing/2014/main" id="{DAFEE3D4-36B9-4B8E-A174-A6F99EF69255}"/>
+                <a16:creationId xmlns:a16="http://schemas.microsoft.com/office/drawing/2014/main" id="{B185425A-8E3E-4298-A0CB-C6D01C5820B4}"/>
               </a:ext>
             </a:extLst>
           </p:cNvPr>
@@ -2728,7 +2728,7 @@
           <p:cNvPr id="2" name="">
             <a:extLst xmlns:a="http://schemas.openxmlformats.org/drawingml/2006/main">
               <a:ext uri="{FF2B5EF4-FFF2-40B4-BE49-F238E27FC236}">
-                <a16:creationId xmlns:a16="http://schemas.microsoft.com/office/drawing/2014/main" id="{B7501C16-3CD0-4326-83B8-EA5562805739}"/>
+                <a16:creationId xmlns:a16="http://schemas.microsoft.com/office/drawing/2014/main" id="{F4BDFFDE-6155-40AA-B0F4-4E31BE6C3D0F}"/>
               </a:ext>
             </a:extLst>
           </p:cNvPr>
@@ -2785,7 +2785,7 @@
           <p:cNvPr id="3" name="">
             <a:extLst xmlns:a="http://schemas.openxmlformats.org/drawingml/2006/main">
               <a:ext uri="{FF2B5EF4-FFF2-40B4-BE49-F238E27FC236}">
-                <a16:creationId xmlns:a16="http://schemas.microsoft.com/office/drawing/2014/main" id="{523E2AB9-57F0-4C7A-86C0-B0F859719096}"/>
+                <a16:creationId xmlns:a16="http://schemas.microsoft.com/office/drawing/2014/main" id="{9F87B61D-52C0-44DE-8A69-7EA223482A6A}"/>
               </a:ext>
             </a:extLst>
           </p:cNvPr>
@@ -2817,7 +2817,7 @@
           <p:cNvPr id="4" name="">
             <a:extLst xmlns:a="http://schemas.openxmlformats.org/drawingml/2006/main">
               <a:ext uri="{FF2B5EF4-FFF2-40B4-BE49-F238E27FC236}">
-                <a16:creationId xmlns:a16="http://schemas.microsoft.com/office/drawing/2014/main" id="{3EDD9DD9-6CD7-4748-8E02-A0A1443C0085}"/>
+                <a16:creationId xmlns:a16="http://schemas.microsoft.com/office/drawing/2014/main" id="{A08756F6-A8CE-4E8E-A82F-3C6F06900513}"/>
               </a:ext>
             </a:extLst>
           </p:cNvPr>
@@ -2874,7 +2874,7 @@
           <p:cNvPr id="5" name="">
             <a:extLst xmlns:a="http://schemas.openxmlformats.org/drawingml/2006/main">
               <a:ext uri="{FF2B5EF4-FFF2-40B4-BE49-F238E27FC236}">
-                <a16:creationId xmlns:a16="http://schemas.microsoft.com/office/drawing/2014/main" id="{9AD519A4-C322-45C3-A5F9-27614742FB5B}"/>
+                <a16:creationId xmlns:a16="http://schemas.microsoft.com/office/drawing/2014/main" id="{0F7C75B4-296E-458E-87D6-E6C24BAC5BAA}"/>
               </a:ext>
             </a:extLst>
           </p:cNvPr>
@@ -2931,7 +2931,7 @@
           <p:cNvPr id="6" name="">
             <a:extLst xmlns:a="http://schemas.openxmlformats.org/drawingml/2006/main">
               <a:ext uri="{FF2B5EF4-FFF2-40B4-BE49-F238E27FC236}">
-                <a16:creationId xmlns:a16="http://schemas.microsoft.com/office/drawing/2014/main" id="{31C829AE-E433-423D-B404-95C5168AB40B}"/>
+                <a16:creationId xmlns:a16="http://schemas.microsoft.com/office/drawing/2014/main" id="{8C590C84-4FB0-44EF-9816-C7B719E7FC06}"/>
               </a:ext>
             </a:extLst>
           </p:cNvPr>
@@ -2963,7 +2963,7 @@
           <p:cNvPr id="7" name="">
             <a:extLst xmlns:a="http://schemas.openxmlformats.org/drawingml/2006/main">
               <a:ext uri="{FF2B5EF4-FFF2-40B4-BE49-F238E27FC236}">
-                <a16:creationId xmlns:a16="http://schemas.microsoft.com/office/drawing/2014/main" id="{D83CA677-5DD9-45FB-A236-1A95F2FB043B}"/>
+                <a16:creationId xmlns:a16="http://schemas.microsoft.com/office/drawing/2014/main" id="{1DDDC3D1-46D7-4884-850D-EC306182920F}"/>
               </a:ext>
             </a:extLst>
           </p:cNvPr>
@@ -3043,7 +3043,7 @@
           <p:cNvPr id="8" name="">
             <a:extLst xmlns:a="http://schemas.openxmlformats.org/drawingml/2006/main">
               <a:ext uri="{FF2B5EF4-FFF2-40B4-BE49-F238E27FC236}">
-                <a16:creationId xmlns:a16="http://schemas.microsoft.com/office/drawing/2014/main" id="{DA59FCBF-083A-4765-9549-88DEF816192E}"/>
+                <a16:creationId xmlns:a16="http://schemas.microsoft.com/office/drawing/2014/main" id="{F9E0787D-3CE2-4F67-AF5F-B785B04B55AE}"/>
               </a:ext>
             </a:extLst>
           </p:cNvPr>
@@ -3100,7 +3100,7 @@
           <p:cNvPr id="9" name="">
             <a:extLst xmlns:a="http://schemas.openxmlformats.org/drawingml/2006/main">
               <a:ext uri="{FF2B5EF4-FFF2-40B4-BE49-F238E27FC236}">
-                <a16:creationId xmlns:a16="http://schemas.microsoft.com/office/drawing/2014/main" id="{DD28B723-42B3-4DA8-8043-61B4534EAA48}"/>
+                <a16:creationId xmlns:a16="http://schemas.microsoft.com/office/drawing/2014/main" id="{4CD8F075-935A-42AA-88EB-4C4093BBF354}"/>
               </a:ext>
             </a:extLst>
           </p:cNvPr>
@@ -3132,7 +3132,7 @@
           <p:cNvPr id="10" name="">
             <a:extLst xmlns:a="http://schemas.openxmlformats.org/drawingml/2006/main">
               <a:ext uri="{FF2B5EF4-FFF2-40B4-BE49-F238E27FC236}">
-                <a16:creationId xmlns:a16="http://schemas.microsoft.com/office/drawing/2014/main" id="{20479832-A704-442B-B945-1850D5F3709F}"/>
+                <a16:creationId xmlns:a16="http://schemas.microsoft.com/office/drawing/2014/main" id="{EFD35688-9D1D-4F81-B0AE-1B02DEEAD6CB}"/>
               </a:ext>
             </a:extLst>
           </p:cNvPr>
@@ -3212,7 +3212,7 @@
           <p:cNvPr id="11" name="">
             <a:extLst xmlns:a="http://schemas.openxmlformats.org/drawingml/2006/main">
               <a:ext uri="{FF2B5EF4-FFF2-40B4-BE49-F238E27FC236}">
-                <a16:creationId xmlns:a16="http://schemas.microsoft.com/office/drawing/2014/main" id="{6A0E3AAA-CC1A-4B3B-AB36-A1C23EFDFD44}"/>
+                <a16:creationId xmlns:a16="http://schemas.microsoft.com/office/drawing/2014/main" id="{691E8ED5-CE61-48A0-8EC5-B9C8CF828671}"/>
               </a:ext>
             </a:extLst>
           </p:cNvPr>
@@ -3269,7 +3269,7 @@
           <p:cNvPr id="12" name="">
             <a:extLst xmlns:a="http://schemas.openxmlformats.org/drawingml/2006/main">
               <a:ext uri="{FF2B5EF4-FFF2-40B4-BE49-F238E27FC236}">
-                <a16:creationId xmlns:a16="http://schemas.microsoft.com/office/drawing/2014/main" id="{EE12C3FB-7BF2-403A-97FD-FC5FED6010CA}"/>
+                <a16:creationId xmlns:a16="http://schemas.microsoft.com/office/drawing/2014/main" id="{AD610F0E-B8EE-4F01-AC7E-E335FF0952A9}"/>
               </a:ext>
             </a:extLst>
           </p:cNvPr>
@@ -3301,7 +3301,7 @@
           <p:cNvPr id="13" name="">
             <a:extLst xmlns:a="http://schemas.openxmlformats.org/drawingml/2006/main">
               <a:ext uri="{FF2B5EF4-FFF2-40B4-BE49-F238E27FC236}">
-                <a16:creationId xmlns:a16="http://schemas.microsoft.com/office/drawing/2014/main" id="{1EFA9AA1-D11D-41C0-82AE-BF411DF57172}"/>
+                <a16:creationId xmlns:a16="http://schemas.microsoft.com/office/drawing/2014/main" id="{DF2BF249-85C1-4200-8D0A-7D003310E819}"/>
               </a:ext>
             </a:extLst>
           </p:cNvPr>
@@ -3371,7 +3371,7 @@
                 <a:ea typeface="Arial"/>
                 <a:cs typeface="Arial"/>
               </a:rPr>
-              <a:t>50 мс</a:t>
+              <a:t>100/150 мс</a:t>
             </a:r>
           </a:p>
         </p:txBody>
@@ -3381,7 +3381,7 @@
           <p:cNvPr id="14" name="">
             <a:extLst xmlns:a="http://schemas.openxmlformats.org/drawingml/2006/main">
               <a:ext uri="{FF2B5EF4-FFF2-40B4-BE49-F238E27FC236}">
-                <a16:creationId xmlns:a16="http://schemas.microsoft.com/office/drawing/2014/main" id="{5C71B9EC-0C6D-43FE-A17C-0BC1EB56E852}"/>
+                <a16:creationId xmlns:a16="http://schemas.microsoft.com/office/drawing/2014/main" id="{A065875E-AA3E-4DA5-BB85-1F2065FB2509}"/>
               </a:ext>
             </a:extLst>
           </p:cNvPr>
@@ -3438,7 +3438,7 @@
           <p:cNvPr id="15" name="">
             <a:extLst xmlns:a="http://schemas.openxmlformats.org/drawingml/2006/main">
               <a:ext uri="{FF2B5EF4-FFF2-40B4-BE49-F238E27FC236}">
-                <a16:creationId xmlns:a16="http://schemas.microsoft.com/office/drawing/2014/main" id="{8E89DCD1-C71E-4243-BBA3-4337CFB33D66}"/>
+                <a16:creationId xmlns:a16="http://schemas.microsoft.com/office/drawing/2014/main" id="{186BA727-CFA1-4FB8-9BD8-0AE93001259F}"/>
               </a:ext>
             </a:extLst>
           </p:cNvPr>
@@ -3470,7 +3470,7 @@
           <p:cNvPr id="16" name="">
             <a:extLst xmlns:a="http://schemas.openxmlformats.org/drawingml/2006/main">
               <a:ext uri="{FF2B5EF4-FFF2-40B4-BE49-F238E27FC236}">
-                <a16:creationId xmlns:a16="http://schemas.microsoft.com/office/drawing/2014/main" id="{CF859270-6879-407E-A064-4AEA1FD59A1B}"/>
+                <a16:creationId xmlns:a16="http://schemas.microsoft.com/office/drawing/2014/main" id="{D253E688-5E9C-437F-A1DF-BDFEB6087A82}"/>
               </a:ext>
             </a:extLst>
           </p:cNvPr>
@@ -3550,7 +3550,7 @@
           <p:cNvPr id="17" name="">
             <a:extLst xmlns:a="http://schemas.openxmlformats.org/drawingml/2006/main">
               <a:ext uri="{FF2B5EF4-FFF2-40B4-BE49-F238E27FC236}">
-                <a16:creationId xmlns:a16="http://schemas.microsoft.com/office/drawing/2014/main" id="{D1C62B42-6A2A-4B40-AC29-E894B21D29B5}"/>
+                <a16:creationId xmlns:a16="http://schemas.microsoft.com/office/drawing/2014/main" id="{5BDE6B17-272B-4DAB-BF3E-EC9616A8ACAD}"/>
               </a:ext>
             </a:extLst>
           </p:cNvPr>
@@ -3582,7 +3582,7 @@
           <p:cNvPr id="18" name="">
             <a:extLst xmlns:a="http://schemas.openxmlformats.org/drawingml/2006/main">
               <a:ext uri="{FF2B5EF4-FFF2-40B4-BE49-F238E27FC236}">
-                <a16:creationId xmlns:a16="http://schemas.microsoft.com/office/drawing/2014/main" id="{96E922CC-10E7-49AB-BC48-ED40A9CDE683}"/>
+                <a16:creationId xmlns:a16="http://schemas.microsoft.com/office/drawing/2014/main" id="{EFF03775-A298-4D6F-9E84-FBD8038B5A71}"/>
               </a:ext>
             </a:extLst>
           </p:cNvPr>
@@ -3662,7 +3662,7 @@
           <p:cNvPr id="19" name="">
             <a:extLst xmlns:a="http://schemas.openxmlformats.org/drawingml/2006/main">
               <a:ext uri="{FF2B5EF4-FFF2-40B4-BE49-F238E27FC236}">
-                <a16:creationId xmlns:a16="http://schemas.microsoft.com/office/drawing/2014/main" id="{EC6387C0-E8A3-4548-88C4-D47C4651DF4C}"/>
+                <a16:creationId xmlns:a16="http://schemas.microsoft.com/office/drawing/2014/main" id="{EF328DD9-33CC-434D-AAFD-AD81BC33D489}"/>
               </a:ext>
             </a:extLst>
           </p:cNvPr>
@@ -3719,7 +3719,7 @@
           <p:cNvPr id="20" name="">
             <a:extLst xmlns:a="http://schemas.openxmlformats.org/drawingml/2006/main">
               <a:ext uri="{FF2B5EF4-FFF2-40B4-BE49-F238E27FC236}">
-                <a16:creationId xmlns:a16="http://schemas.microsoft.com/office/drawing/2014/main" id="{583023F8-76CE-46AF-9095-361F20F2EF6F}"/>
+                <a16:creationId xmlns:a16="http://schemas.microsoft.com/office/drawing/2014/main" id="{1728450A-8522-4B06-8458-396A843641F0}"/>
               </a:ext>
             </a:extLst>
           </p:cNvPr>
@@ -3751,7 +3751,7 @@
           <p:cNvPr id="21" name="">
             <a:extLst xmlns:a="http://schemas.openxmlformats.org/drawingml/2006/main">
               <a:ext uri="{FF2B5EF4-FFF2-40B4-BE49-F238E27FC236}">
-                <a16:creationId xmlns:a16="http://schemas.microsoft.com/office/drawing/2014/main" id="{DA4DAB65-A2CE-411A-805D-1A9E3FE1B7D9}"/>
+                <a16:creationId xmlns:a16="http://schemas.microsoft.com/office/drawing/2014/main" id="{D8ADBEF5-0745-4232-8154-AABF7AFBC545}"/>
               </a:ext>
             </a:extLst>
           </p:cNvPr>
@@ -3831,7 +3831,7 @@
           <p:cNvPr id="22" name="">
             <a:extLst xmlns:a="http://schemas.openxmlformats.org/drawingml/2006/main">
               <a:ext uri="{FF2B5EF4-FFF2-40B4-BE49-F238E27FC236}">
-                <a16:creationId xmlns:a16="http://schemas.microsoft.com/office/drawing/2014/main" id="{B238DC8A-9011-4516-9B07-715E2ED902F6}"/>
+                <a16:creationId xmlns:a16="http://schemas.microsoft.com/office/drawing/2014/main" id="{FFBABB09-3632-4698-A6CB-4AC1F0A5F499}"/>
               </a:ext>
             </a:extLst>
           </p:cNvPr>
@@ -3888,7 +3888,7 @@
           <p:cNvPr id="23" name="">
             <a:extLst xmlns:a="http://schemas.openxmlformats.org/drawingml/2006/main">
               <a:ext uri="{FF2B5EF4-FFF2-40B4-BE49-F238E27FC236}">
-                <a16:creationId xmlns:a16="http://schemas.microsoft.com/office/drawing/2014/main" id="{CBF2E914-0DF4-4ED3-A3C2-4157BC89D3AF}"/>
+                <a16:creationId xmlns:a16="http://schemas.microsoft.com/office/drawing/2014/main" id="{7706729B-21C3-44D1-9194-BBB94B2A85BB}"/>
               </a:ext>
             </a:extLst>
           </p:cNvPr>
@@ -3920,7 +3920,7 @@
           <p:cNvPr id="24" name="">
             <a:extLst xmlns:a="http://schemas.openxmlformats.org/drawingml/2006/main">
               <a:ext uri="{FF2B5EF4-FFF2-40B4-BE49-F238E27FC236}">
-                <a16:creationId xmlns:a16="http://schemas.microsoft.com/office/drawing/2014/main" id="{009636B1-B065-470C-9386-B1BBA6136B03}"/>
+                <a16:creationId xmlns:a16="http://schemas.microsoft.com/office/drawing/2014/main" id="{5F7EF28E-1B22-4A21-B91F-ED41D5608D3D}"/>
               </a:ext>
             </a:extLst>
           </p:cNvPr>
@@ -3977,7 +3977,7 @@
           <p:cNvPr id="25" name="">
             <a:extLst xmlns:a="http://schemas.openxmlformats.org/drawingml/2006/main">
               <a:ext uri="{FF2B5EF4-FFF2-40B4-BE49-F238E27FC236}">
-                <a16:creationId xmlns:a16="http://schemas.microsoft.com/office/drawing/2014/main" id="{FC19073E-C980-4C83-B0F9-CE1D72B12152}"/>
+                <a16:creationId xmlns:a16="http://schemas.microsoft.com/office/drawing/2014/main" id="{DD5995BA-8593-4E34-B8B0-316DAC06C4F7}"/>
               </a:ext>
             </a:extLst>
           </p:cNvPr>
@@ -4034,7 +4034,7 @@
           <p:cNvPr id="26" name="">
             <a:extLst xmlns:a="http://schemas.openxmlformats.org/drawingml/2006/main">
               <a:ext uri="{FF2B5EF4-FFF2-40B4-BE49-F238E27FC236}">
-                <a16:creationId xmlns:a16="http://schemas.microsoft.com/office/drawing/2014/main" id="{45F433BF-EFB6-418A-BB7A-C78429F33A17}"/>
+                <a16:creationId xmlns:a16="http://schemas.microsoft.com/office/drawing/2014/main" id="{B56CC8C7-FF96-4636-B147-28B7BCB14DB5}"/>
               </a:ext>
             </a:extLst>
           </p:cNvPr>
@@ -4066,7 +4066,7 @@
           <p:cNvPr id="27" name="">
             <a:extLst xmlns:a="http://schemas.openxmlformats.org/drawingml/2006/main">
               <a:ext uri="{FF2B5EF4-FFF2-40B4-BE49-F238E27FC236}">
-                <a16:creationId xmlns:a16="http://schemas.microsoft.com/office/drawing/2014/main" id="{4034814C-7D1A-4730-9987-E2240722A728}"/>
+                <a16:creationId xmlns:a16="http://schemas.microsoft.com/office/drawing/2014/main" id="{CEC7B793-D521-4948-B3D9-2ED744F453A9}"/>
               </a:ext>
             </a:extLst>
           </p:cNvPr>
@@ -4146,7 +4146,7 @@
           <p:cNvPr id="28" name="">
             <a:extLst xmlns:a="http://schemas.openxmlformats.org/drawingml/2006/main">
               <a:ext uri="{FF2B5EF4-FFF2-40B4-BE49-F238E27FC236}">
-                <a16:creationId xmlns:a16="http://schemas.microsoft.com/office/drawing/2014/main" id="{B69F3E51-60F6-40FD-9CBF-3465E99EFE78}"/>
+                <a16:creationId xmlns:a16="http://schemas.microsoft.com/office/drawing/2014/main" id="{2514D036-FF08-4BFB-85CA-F7C7F2B14B15}"/>
               </a:ext>
             </a:extLst>
           </p:cNvPr>
@@ -4203,7 +4203,7 @@
           <p:cNvPr id="29" name="">
             <a:extLst xmlns:a="http://schemas.openxmlformats.org/drawingml/2006/main">
               <a:ext uri="{FF2B5EF4-FFF2-40B4-BE49-F238E27FC236}">
-                <a16:creationId xmlns:a16="http://schemas.microsoft.com/office/drawing/2014/main" id="{2F2D528F-6662-4DAB-8049-91E9C6C60953}"/>
+                <a16:creationId xmlns:a16="http://schemas.microsoft.com/office/drawing/2014/main" id="{3BB2FCC3-B1BF-47EA-BE85-E4FDDC2A1015}"/>
               </a:ext>
             </a:extLst>
           </p:cNvPr>
@@ -4235,7 +4235,7 @@
           <p:cNvPr id="30" name="">
             <a:extLst xmlns:a="http://schemas.openxmlformats.org/drawingml/2006/main">
               <a:ext uri="{FF2B5EF4-FFF2-40B4-BE49-F238E27FC236}">
-                <a16:creationId xmlns:a16="http://schemas.microsoft.com/office/drawing/2014/main" id="{D73C6CE5-BD2C-455D-AF2F-B324408B1952}"/>
+                <a16:creationId xmlns:a16="http://schemas.microsoft.com/office/drawing/2014/main" id="{B01E932E-1EAE-48AC-BA27-C0DB75EDDC0C}"/>
               </a:ext>
             </a:extLst>
           </p:cNvPr>
@@ -4292,7 +4292,7 @@
           <p:cNvPr id="31" name="">
             <a:extLst xmlns:a="http://schemas.openxmlformats.org/drawingml/2006/main">
               <a:ext uri="{FF2B5EF4-FFF2-40B4-BE49-F238E27FC236}">
-                <a16:creationId xmlns:a16="http://schemas.microsoft.com/office/drawing/2014/main" id="{1685263C-7619-4B01-A429-5EC9221E3F74}"/>
+                <a16:creationId xmlns:a16="http://schemas.microsoft.com/office/drawing/2014/main" id="{C4AC8DD4-7525-42DF-BFBC-5460256087A0}"/>
               </a:ext>
             </a:extLst>
           </p:cNvPr>
@@ -4349,7 +4349,7 @@
           <p:cNvPr id="32" name="">
             <a:extLst xmlns:a="http://schemas.openxmlformats.org/drawingml/2006/main">
               <a:ext uri="{FF2B5EF4-FFF2-40B4-BE49-F238E27FC236}">
-                <a16:creationId xmlns:a16="http://schemas.microsoft.com/office/drawing/2014/main" id="{6CEA7E16-4AB3-4578-B6C0-D558F52B5F6E}"/>
+                <a16:creationId xmlns:a16="http://schemas.microsoft.com/office/drawing/2014/main" id="{3ACD19A3-B9D7-472E-ACAE-8734AA110528}"/>
               </a:ext>
             </a:extLst>
           </p:cNvPr>
@@ -4360,8 +4360,8 @@
         </p:nvSpPr>
         <p:spPr>
           <a:xfrm xmlns:a="http://schemas.openxmlformats.org/drawingml/2006/main">
-            <a:off x="609600" y="4352925"/>
-            <a:ext cx="10763250" cy="952500"/>
+            <a:off x="609600" y="4371975"/>
+            <a:ext cx="10953750" cy="1028700"/>
           </a:xfrm>
           <a:prstGeom xmlns:a="http://schemas.openxmlformats.org/drawingml/2006/main" prst="rect">
             <a:avLst/>
@@ -4396,7 +4396,7 @@
                 <a:ea typeface="Arial"/>
                 <a:cs typeface="Arial"/>
               </a:rPr>
-              <a:t>Порог уверенности + несколько совпадающих решений.</a:t>
+              <a:t>Оценка модели + разница двух лучших оценок + подтверждение.</a:t>
             </a:r>
           </a:p>
           <a:p xmlns:a="http://schemas.openxmlformats.org/drawingml/2006/main">
@@ -4419,7 +4419,7 @@
                 <a:ea typeface="Arial"/>
                 <a:cs typeface="Arial"/>
               </a:rPr>
-              <a:t>При плохом сигнале или отказе — запрет движения.</a:t>
+              <a:t>Плохой сигнал или отказ → запрет движения.</a:t>
             </a:r>
           </a:p>
         </p:txBody>
@@ -4429,7 +4429,7 @@
           <p:cNvPr id="33" name="">
             <a:extLst xmlns:a="http://schemas.openxmlformats.org/drawingml/2006/main">
               <a:ext uri="{FF2B5EF4-FFF2-40B4-BE49-F238E27FC236}">
-                <a16:creationId xmlns:a16="http://schemas.microsoft.com/office/drawing/2014/main" id="{455A51F4-3EF5-486C-AE76-54D1F8091087}"/>
+                <a16:creationId xmlns:a16="http://schemas.microsoft.com/office/drawing/2014/main" id="{CDDD9906-01EB-4898-96DC-77E66FF34283}"/>
               </a:ext>
             </a:extLst>
           </p:cNvPr>
@@ -4440,8 +4440,8 @@
         </p:nvSpPr>
         <p:spPr>
           <a:xfrm xmlns:a="http://schemas.openxmlformats.org/drawingml/2006/main">
-            <a:off x="609600" y="5562600"/>
-            <a:ext cx="10477500" cy="609600"/>
+            <a:off x="609600" y="5676900"/>
+            <a:ext cx="10858500" cy="628650"/>
           </a:xfrm>
           <a:prstGeom xmlns:a="http://schemas.openxmlformats.org/drawingml/2006/main" prst="rect">
             <a:avLst/>
@@ -4458,7 +4458,7 @@
           <a:lstStyle xmlns:a="http://schemas.openxmlformats.org/drawingml/2006/main"/>
           <a:p xmlns:a="http://schemas.openxmlformats.org/drawingml/2006/main">
             <a:pPr>
-              <a:defRPr sz="1650" b="0">
+              <a:defRPr sz="1725" b="0">
                 <a:solidFill>
                   <a:srgbClr val="59635B"/>
                 </a:solidFill>
@@ -4468,7 +4468,7 @@
               </a:defRPr>
             </a:pPr>
             <a:r>
-              <a:rPr sz="1650" b="0">
+              <a:rPr sz="1725" b="0">
                 <a:solidFill>
                   <a:srgbClr val="59635B"/>
                 </a:solidFill>
@@ -4476,12 +4476,12 @@
                 <a:ea typeface="Arial"/>
                 <a:cs typeface="Arial"/>
               </a:rPr>
-              <a:t>Реализован программный участок от цифрового сигнала до команды.</a:t>
-            </a:r>
-          </a:p>
-          <a:p xmlns:a="http://schemas.openxmlformats.org/drawingml/2006/main">
-            <a:pPr>
-              <a:defRPr sz="1650" b="0">
+              <a:t>Проверка не исправляет уверенный неправильный ответ.</a:t>
+            </a:r>
+          </a:p>
+          <a:p xmlns:a="http://schemas.openxmlformats.org/drawingml/2006/main">
+            <a:pPr>
+              <a:defRPr sz="1725" b="0">
                 <a:solidFill>
                   <a:srgbClr val="59635B"/>
                 </a:solidFill>
@@ -4491,7 +4491,7 @@
               </a:defRPr>
             </a:pPr>
             <a:r>
-              <a:rPr sz="1650" b="0">
+              <a:rPr sz="1725" b="0">
                 <a:solidFill>
                   <a:srgbClr val="59635B"/>
                 </a:solidFill>
@@ -4499,7 +4499,7 @@
                 <a:ea typeface="Arial"/>
                 <a:cs typeface="Arial"/>
               </a:rPr>
-              <a:t>Съём, связь и привод пока остаются частью аппаратного проекта.</a:t>
+              <a:t>На приводе нужен независимый таймер отсутствия команд.</a:t>
             </a:r>
           </a:p>
         </p:txBody>
@@ -4507,7 +4507,7 @@
     </p:spTree>
     <p:extLst>
       <p:ext uri="{BB962C8B-B14F-4D97-AF65-F5344CB8AC3E}">
-        <p14:creationId xmlns:p14="http://schemas.microsoft.com/office/powerpoint/2010/main" val="928062171"/>
+        <p14:creationId xmlns:p14="http://schemas.microsoft.com/office/powerpoint/2010/main" val="1183734111"/>
       </p:ext>
     </p:extLst>
   </p:cSld>
@@ -4538,7 +4538,7 @@
           <p:cNvPr id="6" name="">
             <a:extLst xmlns:a="http://schemas.openxmlformats.org/drawingml/2006/main">
               <a:ext uri="{FF2B5EF4-FFF2-40B4-BE49-F238E27FC236}">
-                <a16:creationId xmlns:a16="http://schemas.microsoft.com/office/drawing/2014/main" id="{FCA8F49F-AE6F-463F-8B88-E96FB8B93A04}"/>
+                <a16:creationId xmlns:a16="http://schemas.microsoft.com/office/drawing/2014/main" id="{DED34913-950A-483C-9808-1A0DE8D71B91}"/>
               </a:ext>
             </a:extLst>
           </p:cNvPr>
@@ -4585,7 +4585,7 @@
                 <a:ea typeface="Arial"/>
                 <a:cs typeface="Arial"/>
               </a:rPr>
-              <a:t>Как проведён эксперимент</a:t>
+              <a:t>Две модели, два новых участника</a:t>
             </a:r>
           </a:p>
         </p:txBody>
@@ -4595,7 +4595,7 @@
           <p:cNvPr id="2" name="">
             <a:extLst xmlns:a="http://schemas.openxmlformats.org/drawingml/2006/main">
               <a:ext uri="{FF2B5EF4-FFF2-40B4-BE49-F238E27FC236}">
-                <a16:creationId xmlns:a16="http://schemas.microsoft.com/office/drawing/2014/main" id="{96F6DD7A-524C-4119-816A-779E2A9D337B}"/>
+                <a16:creationId xmlns:a16="http://schemas.microsoft.com/office/drawing/2014/main" id="{A0362354-2FA7-4A5F-BAD1-9C1772523134}"/>
               </a:ext>
             </a:extLst>
           </p:cNvPr>
@@ -4647,129 +4647,26 @@
           </a:p>
         </p:txBody>
       </p:sp>
-      <p:sp>
-        <p:nvSpPr>
-          <p:cNvPr id="3" name="">
-            <a:extLst xmlns:a="http://schemas.openxmlformats.org/drawingml/2006/main">
-              <a:ext uri="{FF2B5EF4-FFF2-40B4-BE49-F238E27FC236}">
-                <a16:creationId xmlns:a16="http://schemas.microsoft.com/office/drawing/2014/main" id="{19DA50E7-0752-4522-8ECA-3E8EC10DFF4B}"/>
-              </a:ext>
-            </a:extLst>
-          </p:cNvPr>
-          <p:cNvSpPr>
-            <a:spLocks xmlns:a="http://schemas.openxmlformats.org/drawingml/2006/main" noGrp="1"/>
-          </p:cNvSpPr>
-          <p:nvPr/>
-        </p:nvSpPr>
-        <p:spPr>
-          <a:xfrm xmlns:a="http://schemas.openxmlformats.org/drawingml/2006/main">
-            <a:off x="609600" y="1238250"/>
-            <a:ext cx="10572750" cy="1447800"/>
-          </a:xfrm>
-          <a:prstGeom xmlns:a="http://schemas.openxmlformats.org/drawingml/2006/main" prst="rect">
-            <a:avLst/>
-          </a:prstGeom>
-          <a:noFill xmlns:a="http://schemas.openxmlformats.org/drawingml/2006/main"/>
-          <a:ln xmlns:a="http://schemas.openxmlformats.org/drawingml/2006/main" w="0">
-            <a:noFill/>
-          </a:ln>
-        </p:spPr>
-        <p:txBody>
-          <a:bodyPr xmlns:a="http://schemas.openxmlformats.org/drawingml/2006/main">
-            <a:noAutofit/>
-          </a:bodyPr>
-          <a:lstStyle xmlns:a="http://schemas.openxmlformats.org/drawingml/2006/main"/>
-          <a:p xmlns:a="http://schemas.openxmlformats.org/drawingml/2006/main">
-            <a:pPr>
-              <a:defRPr sz="2250" b="0">
-                <a:solidFill>
-                  <a:srgbClr val="232A25"/>
-                </a:solidFill>
-                <a:latin typeface="Arial"/>
-                <a:ea typeface="Arial"/>
-                <a:cs typeface="Arial"/>
-              </a:defRPr>
-            </a:pPr>
-            <a:r>
-              <a:rPr sz="2250" b="0">
-                <a:solidFill>
-                  <a:srgbClr val="232A25"/>
-                </a:solidFill>
-                <a:latin typeface="Arial"/>
-                <a:ea typeface="Arial"/>
-                <a:cs typeface="Arial"/>
-              </a:rPr>
-              <a:t>Повторения 1, 3, 4 — обучение</a:t>
-            </a:r>
-          </a:p>
-          <a:p xmlns:a="http://schemas.openxmlformats.org/drawingml/2006/main">
-            <a:pPr>
-              <a:defRPr sz="2250" b="0">
-                <a:solidFill>
-                  <a:srgbClr val="232A25"/>
-                </a:solidFill>
-                <a:latin typeface="Arial"/>
-                <a:ea typeface="Arial"/>
-                <a:cs typeface="Arial"/>
-              </a:defRPr>
-            </a:pPr>
-            <a:r>
-              <a:rPr sz="2250" b="0">
-                <a:solidFill>
-                  <a:srgbClr val="232A25"/>
-                </a:solidFill>
-                <a:latin typeface="Arial"/>
-                <a:ea typeface="Arial"/>
-                <a:cs typeface="Arial"/>
-              </a:rPr>
-              <a:t>Повторение 2 — настройка порога</a:t>
-            </a:r>
-          </a:p>
-          <a:p xmlns:a="http://schemas.openxmlformats.org/drawingml/2006/main">
-            <a:pPr>
-              <a:defRPr sz="2250" b="0">
-                <a:solidFill>
-                  <a:srgbClr val="232A25"/>
-                </a:solidFill>
-                <a:latin typeface="Arial"/>
-                <a:ea typeface="Arial"/>
-                <a:cs typeface="Arial"/>
-              </a:defRPr>
-            </a:pPr>
-            <a:r>
-              <a:rPr sz="2250" b="0">
-                <a:solidFill>
-                  <a:srgbClr val="232A25"/>
-                </a:solidFill>
-                <a:latin typeface="Arial"/>
-                <a:ea typeface="Arial"/>
-                <a:cs typeface="Arial"/>
-              </a:rPr>
-              <a:t>Повторения 5, 6 — итоговый тест</a:t>
-            </a:r>
-          </a:p>
-        </p:txBody>
-      </p:sp>
       <p:graphicFrame>
         <p:nvGraphicFramePr>
-          <p:cNvPr id="9" name=""/>
+          <p:cNvPr id="8" name=""/>
           <p:cNvGraphicFramePr/>
           <p:nvPr/>
         </p:nvGraphicFramePr>
         <p:xfrm>
-          <a:off xmlns:a="http://schemas.openxmlformats.org/drawingml/2006/main" x="609600" y="3143250"/>
-          <a:ext xmlns:a="http://schemas.openxmlformats.org/drawingml/2006/main" cx="10953750" cy="1857375"/>
+          <a:off xmlns:a="http://schemas.openxmlformats.org/drawingml/2006/main" x="609600" y="1381125"/>
+          <a:ext xmlns:a="http://schemas.openxmlformats.org/drawingml/2006/main" cx="10953750" cy="2276475"/>
         </p:xfrm>
         <a:graphic xmlns:a="http://schemas.openxmlformats.org/drawingml/2006/main">
           <a:graphicData uri="http://schemas.openxmlformats.org/drawingml/2006/table">
             <a:tbl>
               <a:tblPr/>
               <a:tblGrid>
-                <a:gridCol w="5476875"/>
-                <a:gridCol w="2762250"/>
-                <a:gridCol w="2714625"/>
+                <a:gridCol w="2667000"/>
+                <a:gridCol w="4143375"/>
+                <a:gridCol w="4143375"/>
               </a:tblGrid>
-              <a:tr h="619125">
+              <a:tr h="758825">
                 <a:tc>
                   <a:txBody>
                     <a:bodyPr/>
@@ -4808,7 +4705,7 @@
                           <a:ea typeface="Arial"/>
                           <a:cs typeface="Arial"/>
                         </a:rPr>
-                        <a:t>Точность окон</a:t>
+                        <a:t>S2: точность / F1</a:t>
                       </a:r>
                     </a:p>
                   </a:txBody>
@@ -4832,7 +4729,7 @@
                           <a:ea typeface="Arial"/>
                           <a:cs typeface="Arial"/>
                         </a:rPr>
-                        <a:t>Macro-F1</a:t>
+                        <a:t>S3: точность / F1</a:t>
                       </a:r>
                     </a:p>
                   </a:txBody>
@@ -4843,7 +4740,7 @@
                   </a:tcPr>
                 </a:tc>
               </a:tr>
-              <a:tr h="619125">
+              <a:tr h="758825">
                 <a:tc>
                   <a:txBody>
                     <a:bodyPr/>
@@ -4882,7 +4779,7 @@
                           <a:ea typeface="Arial"/>
                           <a:cs typeface="Arial"/>
                         </a:rPr>
-                        <a:t>48,7%</a:t>
+                        <a:t>57,4% / 0.534</a:t>
                       </a:r>
                     </a:p>
                   </a:txBody>
@@ -4906,7 +4803,7 @@
                           <a:ea typeface="Arial"/>
                           <a:cs typeface="Arial"/>
                         </a:rPr>
-                        <a:t>0,432</a:t>
+                        <a:t>47,7% / 0.451</a:t>
                       </a:r>
                     </a:p>
                   </a:txBody>
@@ -4917,7 +4814,7 @@
                   </a:tcPr>
                 </a:tc>
               </a:tr>
-              <a:tr h="619125">
+              <a:tr h="758825">
                 <a:tc>
                   <a:txBody>
                     <a:bodyPr/>
@@ -4956,7 +4853,7 @@
                           <a:ea typeface="Arial"/>
                           <a:cs typeface="Arial"/>
                         </a:rPr>
-                        <a:t>55,4%</a:t>
+                        <a:t>65,2% / 0.602</a:t>
                       </a:r>
                     </a:p>
                   </a:txBody>
@@ -4980,7 +4877,7 @@
                           <a:ea typeface="Arial"/>
                           <a:cs typeface="Arial"/>
                         </a:rPr>
-                        <a:t>0,500</a:t>
+                        <a:t>57,7% / 0.541</a:t>
                       </a:r>
                     </a:p>
                   </a:txBody>
@@ -4997,10 +4894,10 @@
       </p:graphicFrame>
       <p:sp>
         <p:nvSpPr>
-          <p:cNvPr id="5" name="">
+          <p:cNvPr id="4" name="">
             <a:extLst xmlns:a="http://schemas.openxmlformats.org/drawingml/2006/main">
               <a:ext uri="{FF2B5EF4-FFF2-40B4-BE49-F238E27FC236}">
-                <a16:creationId xmlns:a16="http://schemas.microsoft.com/office/drawing/2014/main" id="{1BCF3A61-4CB8-4D2B-938A-F4D797E86B1D}"/>
+                <a16:creationId xmlns:a16="http://schemas.microsoft.com/office/drawing/2014/main" id="{2FD09E43-2108-441C-B386-2EEDAB50AFE3}"/>
               </a:ext>
             </a:extLst>
           </p:cNvPr>
@@ -5011,8 +4908,8 @@
         </p:nvSpPr>
         <p:spPr>
           <a:xfrm xmlns:a="http://schemas.openxmlformats.org/drawingml/2006/main">
-            <a:off x="609600" y="5391150"/>
-            <a:ext cx="10668000" cy="723900"/>
+            <a:off x="609600" y="4048125"/>
+            <a:ext cx="10858500" cy="904875"/>
           </a:xfrm>
           <a:prstGeom xmlns:a="http://schemas.openxmlformats.org/drawingml/2006/main" prst="rect">
             <a:avLst/>
@@ -5029,48 +4926,128 @@
           <a:lstStyle xmlns:a="http://schemas.openxmlformats.org/drawingml/2006/main"/>
           <a:p xmlns:a="http://schemas.openxmlformats.org/drawingml/2006/main">
             <a:pPr>
-              <a:defRPr sz="1800" b="0">
-                <a:solidFill>
-                  <a:srgbClr val="59635B"/>
-                </a:solidFill>
-                <a:latin typeface="Arial"/>
-                <a:ea typeface="Arial"/>
-                <a:cs typeface="Arial"/>
-              </a:defRPr>
-            </a:pPr>
-            <a:r>
-              <a:rPr sz="1800" b="0">
-                <a:solidFill>
-                  <a:srgbClr val="59635B"/>
-                </a:solidFill>
-                <a:latin typeface="Arial"/>
-                <a:ea typeface="Arial"/>
-                <a:cs typeface="Arial"/>
-              </a:rPr>
-              <a:t>Один человек, 10 тестовых движений, 4574 окна.</a:t>
-            </a:r>
-          </a:p>
-          <a:p xmlns:a="http://schemas.openxmlformats.org/drawingml/2006/main">
-            <a:pPr>
-              <a:defRPr sz="1800" b="0">
-                <a:solidFill>
-                  <a:srgbClr val="59635B"/>
-                </a:solidFill>
-                <a:latin typeface="Arial"/>
-                <a:ea typeface="Arial"/>
-                <a:cs typeface="Arial"/>
-              </a:defRPr>
-            </a:pPr>
-            <a:r>
-              <a:rPr sz="1800" b="0">
-                <a:solidFill>
-                  <a:srgbClr val="59635B"/>
-                </a:solidFill>
-                <a:latin typeface="Arial"/>
-                <a:ea typeface="Arial"/>
-                <a:cs typeface="Arial"/>
-              </a:rPr>
-              <a:t>Пересекающиеся окна одного повтора остаются в одной части выборки.</a:t>
+              <a:defRPr sz="2100" b="0">
+                <a:solidFill>
+                  <a:srgbClr val="232A25"/>
+                </a:solidFill>
+                <a:latin typeface="Arial"/>
+                <a:ea typeface="Arial"/>
+                <a:cs typeface="Arial"/>
+              </a:defRPr>
+            </a:pPr>
+            <a:r>
+              <a:rPr sz="2100" b="0">
+                <a:solidFill>
+                  <a:srgbClr val="232A25"/>
+                </a:solidFill>
+                <a:latin typeface="Arial"/>
+                <a:ea typeface="Arial"/>
+                <a:cs typeface="Arial"/>
+              </a:rPr>
+              <a:t>На S1 сравнены 24 конфигурации. Выбор закреплён до теста.</a:t>
+            </a:r>
+          </a:p>
+          <a:p xmlns:a="http://schemas.openxmlformats.org/drawingml/2006/main">
+            <a:pPr>
+              <a:defRPr sz="2100" b="0">
+                <a:solidFill>
+                  <a:srgbClr val="232A25"/>
+                </a:solidFill>
+                <a:latin typeface="Arial"/>
+                <a:ea typeface="Arial"/>
+                <a:cs typeface="Arial"/>
+              </a:defRPr>
+            </a:pPr>
+            <a:r>
+              <a:rPr sz="2100" b="0">
+                <a:solidFill>
+                  <a:srgbClr val="232A25"/>
+                </a:solidFill>
+                <a:latin typeface="Arial"/>
+                <a:ea typeface="Arial"/>
+                <a:cs typeface="Arial"/>
+              </a:rPr>
+              <a:t>LDA: обычные признаки, 150 мс. SVM: логарифмы, 100 мс.</a:t>
+            </a:r>
+          </a:p>
+        </p:txBody>
+      </p:sp>
+      <p:sp>
+        <p:nvSpPr>
+          <p:cNvPr id="5" name="">
+            <a:extLst xmlns:a="http://schemas.openxmlformats.org/drawingml/2006/main">
+              <a:ext uri="{FF2B5EF4-FFF2-40B4-BE49-F238E27FC236}">
+                <a16:creationId xmlns:a16="http://schemas.microsoft.com/office/drawing/2014/main" id="{8EE0E966-F35A-4935-976E-0E742B2B7F21}"/>
+              </a:ext>
+            </a:extLst>
+          </p:cNvPr>
+          <p:cNvSpPr>
+            <a:spLocks xmlns:a="http://schemas.openxmlformats.org/drawingml/2006/main" noGrp="1"/>
+          </p:cNvSpPr>
+          <p:nvPr/>
+        </p:nvSpPr>
+        <p:spPr>
+          <a:xfrm xmlns:a="http://schemas.openxmlformats.org/drawingml/2006/main">
+            <a:off x="609600" y="5381625"/>
+            <a:ext cx="10858500" cy="828675"/>
+          </a:xfrm>
+          <a:prstGeom xmlns:a="http://schemas.openxmlformats.org/drawingml/2006/main" prst="rect">
+            <a:avLst/>
+          </a:prstGeom>
+          <a:noFill xmlns:a="http://schemas.openxmlformats.org/drawingml/2006/main"/>
+          <a:ln xmlns:a="http://schemas.openxmlformats.org/drawingml/2006/main" w="0">
+            <a:noFill/>
+          </a:ln>
+        </p:spPr>
+        <p:txBody>
+          <a:bodyPr xmlns:a="http://schemas.openxmlformats.org/drawingml/2006/main">
+            <a:noAutofit/>
+          </a:bodyPr>
+          <a:lstStyle xmlns:a="http://schemas.openxmlformats.org/drawingml/2006/main"/>
+          <a:p xmlns:a="http://schemas.openxmlformats.org/drawingml/2006/main">
+            <a:pPr>
+              <a:defRPr sz="2025" b="1">
+                <a:solidFill>
+                  <a:srgbClr val="28533A"/>
+                </a:solidFill>
+                <a:latin typeface="Arial"/>
+                <a:ea typeface="Arial"/>
+                <a:cs typeface="Arial"/>
+              </a:defRPr>
+            </a:pPr>
+            <a:r>
+              <a:rPr sz="2025" b="1">
+                <a:solidFill>
+                  <a:srgbClr val="28533A"/>
+                </a:solidFill>
+                <a:latin typeface="Arial"/>
+                <a:ea typeface="Arial"/>
+                <a:cs typeface="Arial"/>
+              </a:rPr>
+              <a:t>SVM на одинаковых временных точках, старая → новая версия:</a:t>
+            </a:r>
+          </a:p>
+          <a:p xmlns:a="http://schemas.openxmlformats.org/drawingml/2006/main">
+            <a:pPr>
+              <a:defRPr sz="2025" b="1">
+                <a:solidFill>
+                  <a:srgbClr val="28533A"/>
+                </a:solidFill>
+                <a:latin typeface="Arial"/>
+                <a:ea typeface="Arial"/>
+                <a:cs typeface="Arial"/>
+              </a:defRPr>
+            </a:pPr>
+            <a:r>
+              <a:rPr sz="2025" b="1">
+                <a:solidFill>
+                  <a:srgbClr val="28533A"/>
+                </a:solidFill>
+                <a:latin typeface="Arial"/>
+                <a:ea typeface="Arial"/>
+                <a:cs typeface="Arial"/>
+              </a:rPr>
+              <a:t>S2: 61,7 → 65,2%     S3: 52,0 → 57,7%</a:t>
             </a:r>
           </a:p>
         </p:txBody>
@@ -5078,7 +5055,7 @@
     </p:spTree>
     <p:extLst>
       <p:ext uri="{BB962C8B-B14F-4D97-AF65-F5344CB8AC3E}">
-        <p14:creationId xmlns:p14="http://schemas.microsoft.com/office/powerpoint/2010/main" val="1279189122"/>
+        <p14:creationId xmlns:p14="http://schemas.microsoft.com/office/powerpoint/2010/main" val="582443325"/>
       </p:ext>
     </p:extLst>
   </p:cSld>
@@ -5106,10 +5083,10 @@
       </p:grpSpPr>
       <p:sp>
         <p:nvSpPr>
-          <p:cNvPr id="5" name="">
+          <p:cNvPr id="6" name="">
             <a:extLst xmlns:a="http://schemas.openxmlformats.org/drawingml/2006/main">
               <a:ext uri="{FF2B5EF4-FFF2-40B4-BE49-F238E27FC236}">
-                <a16:creationId xmlns:a16="http://schemas.microsoft.com/office/drawing/2014/main" id="{B7012B5A-5D76-4FED-96E2-122CBFB321D3}"/>
+                <a16:creationId xmlns:a16="http://schemas.microsoft.com/office/drawing/2014/main" id="{F96AEB53-938A-4121-969E-A9DF4BEC0CC7}"/>
               </a:ext>
             </a:extLst>
           </p:cNvPr>
@@ -5156,7 +5133,7 @@
                 <a:ea typeface="Arial"/>
                 <a:cs typeface="Arial"/>
               </a:rPr>
-              <a:t>Проверка команд: результат SVM</a:t>
+              <a:t>Меньше переключений — какой ценой?</a:t>
             </a:r>
           </a:p>
         </p:txBody>
@@ -5166,7 +5143,7 @@
           <p:cNvPr id="2" name="">
             <a:extLst xmlns:a="http://schemas.openxmlformats.org/drawingml/2006/main">
               <a:ext uri="{FF2B5EF4-FFF2-40B4-BE49-F238E27FC236}">
-                <a16:creationId xmlns:a16="http://schemas.microsoft.com/office/drawing/2014/main" id="{DA155A91-603C-46D8-A381-91387C4570E7}"/>
+                <a16:creationId xmlns:a16="http://schemas.microsoft.com/office/drawing/2014/main" id="{E3C6F277-EB06-4350-A110-55A38800237C}"/>
               </a:ext>
             </a:extLst>
           </p:cNvPr>
@@ -5220,25 +5197,24 @@
       </p:sp>
       <p:graphicFrame>
         <p:nvGraphicFramePr>
-          <p:cNvPr id="7" name=""/>
+          <p:cNvPr id="8" name=""/>
           <p:cNvGraphicFramePr/>
           <p:nvPr/>
         </p:nvGraphicFramePr>
         <p:xfrm>
-          <a:off xmlns:a="http://schemas.openxmlformats.org/drawingml/2006/main" x="609600" y="1304925"/>
-          <a:ext xmlns:a="http://schemas.openxmlformats.org/drawingml/2006/main" cx="10953750" cy="3314700"/>
+          <a:off xmlns:a="http://schemas.openxmlformats.org/drawingml/2006/main" x="609600" y="1333500"/>
+          <a:ext xmlns:a="http://schemas.openxmlformats.org/drawingml/2006/main" cx="10953750" cy="3238500"/>
         </p:xfrm>
         <a:graphic xmlns:a="http://schemas.openxmlformats.org/drawingml/2006/main">
           <a:graphicData uri="http://schemas.openxmlformats.org/drawingml/2006/table">
             <a:tbl>
               <a:tblPr/>
               <a:tblGrid>
-                <a:gridCol w="3381375"/>
-                <a:gridCol w="2381250"/>
-                <a:gridCol w="1857375"/>
-                <a:gridCol w="3333750"/>
+                <a:gridCol w="6286500"/>
+                <a:gridCol w="2333625"/>
+                <a:gridCol w="2333625"/>
               </a:tblGrid>
-              <a:tr h="662940">
+              <a:tr h="647700">
                 <a:tc>
                   <a:txBody>
                     <a:bodyPr/>
@@ -5253,7 +5229,7 @@
                           <a:ea typeface="Arial"/>
                           <a:cs typeface="Arial"/>
                         </a:rPr>
-                        <a:t>Режим</a:t>
+                        <a:t>SVM</a:t>
                       </a:r>
                     </a:p>
                   </a:txBody>
@@ -5277,20 +5253,7 @@
                           <a:ea typeface="Arial"/>
                           <a:cs typeface="Arial"/>
                         </a:rPr>
-                        <a:t>Ошибочные</a:t>
-                      </a:r>
-                    </a:p>
-                    <a:p>
-                      <a:r>
-                        <a:rPr sz="1725" b="1">
-                          <a:solidFill>
-                            <a:srgbClr val="28533A"/>
-                          </a:solidFill>
-                          <a:latin typeface="Arial"/>
-                          <a:ea typeface="Arial"/>
-                          <a:cs typeface="Arial"/>
-                        </a:rPr>
-                        <a:t>переключения</a:t>
+                        <a:t>S2</a:t>
                       </a:r>
                     </a:p>
                   </a:txBody>
@@ -5314,44 +5277,7 @@
                           <a:ea typeface="Arial"/>
                           <a:cs typeface="Arial"/>
                         </a:rPr>
-                        <a:t>Отказы</a:t>
-                      </a:r>
-                    </a:p>
-                  </a:txBody>
-                  <a:tcPr marL="133350" marR="114300" marT="95250" marB="95250">
-                    <a:solidFill>
-                      <a:srgbClr val="ECF1EB"/>
-                    </a:solidFill>
-                  </a:tcPr>
-                </a:tc>
-                <a:tc>
-                  <a:txBody>
-                    <a:bodyPr/>
-                    <a:lstStyle/>
-                    <a:p>
-                      <a:r>
-                        <a:rPr sz="1725" b="1">
-                          <a:solidFill>
-                            <a:srgbClr val="28533A"/>
-                          </a:solidFill>
-                          <a:latin typeface="Arial"/>
-                          <a:ea typeface="Arial"/>
-                          <a:cs typeface="Arial"/>
-                        </a:rPr>
-                        <a:t>Ошибки среди</a:t>
-                      </a:r>
-                    </a:p>
-                    <a:p>
-                      <a:r>
-                        <a:rPr sz="1725" b="1">
-                          <a:solidFill>
-                            <a:srgbClr val="28533A"/>
-                          </a:solidFill>
-                          <a:latin typeface="Arial"/>
-                          <a:ea typeface="Arial"/>
-                          <a:cs typeface="Arial"/>
-                        </a:rPr>
-                        <a:t>выданных команд</a:t>
+                        <a:t>S3</a:t>
                       </a:r>
                     </a:p>
                   </a:txBody>
@@ -5362,7 +5288,7 @@
                   </a:tcPr>
                 </a:tc>
               </a:tr>
-              <a:tr h="662940">
+              <a:tr h="647700">
                 <a:tc>
                   <a:txBody>
                     <a:bodyPr/>
@@ -5377,7 +5303,7 @@
                           <a:ea typeface="Arial"/>
                           <a:cs typeface="Arial"/>
                         </a:rPr>
-                        <a:t>Без проверки</a:t>
+                        <a:t>Ошибочные переключения/мин: до → после</a:t>
                       </a:r>
                     </a:p>
                   </a:txBody>
@@ -5401,7 +5327,7 @@
                           <a:ea typeface="Arial"/>
                           <a:cs typeface="Arial"/>
                         </a:rPr>
-                        <a:t>535</a:t>
+                        <a:t>482 → 178</a:t>
                       </a:r>
                     </a:p>
                   </a:txBody>
@@ -5425,7 +5351,33 @@
                           <a:ea typeface="Arial"/>
                           <a:cs typeface="Arial"/>
                         </a:rPr>
-                        <a:t>0,0%</a:t>
+                        <a:t>546 → 175</a:t>
+                      </a:r>
+                    </a:p>
+                  </a:txBody>
+                  <a:tcPr marL="133350" marR="114300" marT="95250" marB="95250">
+                    <a:solidFill>
+                      <a:srgbClr val="FFFFFF"/>
+                    </a:solidFill>
+                  </a:tcPr>
+                </a:tc>
+              </a:tr>
+              <a:tr h="647700">
+                <a:tc>
+                  <a:txBody>
+                    <a:bodyPr/>
+                    <a:lstStyle/>
+                    <a:p>
+                      <a:r>
+                        <a:rPr sz="1725">
+                          <a:solidFill>
+                            <a:srgbClr val="232A25"/>
+                          </a:solidFill>
+                          <a:latin typeface="Arial"/>
+                          <a:ea typeface="Arial"/>
+                          <a:cs typeface="Arial"/>
+                        </a:rPr>
+                        <a:t>Принято после проверки</a:t>
                       </a:r>
                     </a:p>
                   </a:txBody>
@@ -5449,33 +5401,7 @@
                           <a:ea typeface="Arial"/>
                           <a:cs typeface="Arial"/>
                         </a:rPr>
-                        <a:t>44,6%</a:t>
-                      </a:r>
-                    </a:p>
-                  </a:txBody>
-                  <a:tcPr marL="133350" marR="114300" marT="95250" marB="95250">
-                    <a:solidFill>
-                      <a:srgbClr val="FFFFFF"/>
-                    </a:solidFill>
-                  </a:tcPr>
-                </a:tc>
-              </a:tr>
-              <a:tr h="662940">
-                <a:tc>
-                  <a:txBody>
-                    <a:bodyPr/>
-                    <a:lstStyle/>
-                    <a:p>
-                      <a:r>
-                        <a:rPr sz="1725">
-                          <a:solidFill>
-                            <a:srgbClr val="232A25"/>
-                          </a:solidFill>
-                          <a:latin typeface="Arial"/>
-                          <a:ea typeface="Arial"/>
-                          <a:cs typeface="Arial"/>
-                        </a:rPr>
-                        <a:t>Только порог</a:t>
+                        <a:t>86,5%</a:t>
                       </a:r>
                     </a:p>
                   </a:txBody>
@@ -5499,7 +5425,33 @@
                           <a:ea typeface="Arial"/>
                           <a:cs typeface="Arial"/>
                         </a:rPr>
-                        <a:t>118</a:t>
+                        <a:t>67,8%</a:t>
+                      </a:r>
+                    </a:p>
+                  </a:txBody>
+                  <a:tcPr marL="133350" marR="114300" marT="95250" marB="95250">
+                    <a:solidFill>
+                      <a:srgbClr val="FFFFFF"/>
+                    </a:solidFill>
+                  </a:tcPr>
+                </a:tc>
+              </a:tr>
+              <a:tr h="647700">
+                <a:tc>
+                  <a:txBody>
+                    <a:bodyPr/>
+                    <a:lstStyle/>
+                    <a:p>
+                      <a:r>
+                        <a:rPr sz="1725">
+                          <a:solidFill>
+                            <a:srgbClr val="232A25"/>
+                          </a:solidFill>
+                          <a:latin typeface="Arial"/>
+                          <a:ea typeface="Arial"/>
+                          <a:cs typeface="Arial"/>
+                        </a:rPr>
+                        <a:t>Ошибки среди принятых</a:t>
                       </a:r>
                     </a:p>
                   </a:txBody>
@@ -5523,7 +5475,7 @@
                           <a:ea typeface="Arial"/>
                           <a:cs typeface="Arial"/>
                         </a:rPr>
-                        <a:t>47,1%</a:t>
+                        <a:t>29,3%</a:t>
                       </a:r>
                     </a:p>
                   </a:txBody>
@@ -5547,7 +5499,7 @@
                           <a:ea typeface="Arial"/>
                           <a:cs typeface="Arial"/>
                         </a:rPr>
-                        <a:t>34,0%</a:t>
+                        <a:t>32,0%</a:t>
                       </a:r>
                     </a:p>
                   </a:txBody>
@@ -5558,7 +5510,7 @@
                   </a:tcPr>
                 </a:tc>
               </a:tr>
-              <a:tr h="662940">
+              <a:tr h="647700">
                 <a:tc>
                   <a:txBody>
                     <a:bodyPr/>
@@ -5573,7 +5525,7 @@
                           <a:ea typeface="Arial"/>
                           <a:cs typeface="Arial"/>
                         </a:rPr>
-                        <a:t>Подтверждение</a:t>
+                        <a:t>Полнота распознавания покоя</a:t>
                       </a:r>
                     </a:p>
                   </a:txBody>
@@ -5597,7 +5549,7 @@
                           <a:ea typeface="Arial"/>
                           <a:cs typeface="Arial"/>
                         </a:rPr>
-                        <a:t>201</a:t>
+                        <a:t>14,7%</a:t>
                       </a:r>
                     </a:p>
                   </a:txBody>
@@ -5621,129 +5573,7 @@
                           <a:ea typeface="Arial"/>
                           <a:cs typeface="Arial"/>
                         </a:rPr>
-                        <a:t>19,1%</a:t>
-                      </a:r>
-                    </a:p>
-                  </a:txBody>
-                  <a:tcPr marL="133350" marR="114300" marT="95250" marB="95250">
-                    <a:solidFill>
-                      <a:srgbClr val="FFFFFF"/>
-                    </a:solidFill>
-                  </a:tcPr>
-                </a:tc>
-                <a:tc>
-                  <a:txBody>
-                    <a:bodyPr/>
-                    <a:lstStyle/>
-                    <a:p>
-                      <a:r>
-                        <a:rPr sz="1725">
-                          <a:solidFill>
-                            <a:srgbClr val="232A25"/>
-                          </a:solidFill>
-                          <a:latin typeface="Arial"/>
-                          <a:ea typeface="Arial"/>
-                          <a:cs typeface="Arial"/>
-                        </a:rPr>
-                        <a:t>39,7%</a:t>
-                      </a:r>
-                    </a:p>
-                  </a:txBody>
-                  <a:tcPr marL="133350" marR="114300" marT="95250" marB="95250">
-                    <a:solidFill>
-                      <a:srgbClr val="FFFFFF"/>
-                    </a:solidFill>
-                  </a:tcPr>
-                </a:tc>
-              </a:tr>
-              <a:tr h="662940">
-                <a:tc>
-                  <a:txBody>
-                    <a:bodyPr/>
-                    <a:lstStyle/>
-                    <a:p>
-                      <a:r>
-                        <a:rPr sz="1725">
-                          <a:solidFill>
-                            <a:srgbClr val="232A25"/>
-                          </a:solidFill>
-                          <a:latin typeface="Arial"/>
-                          <a:ea typeface="Arial"/>
-                          <a:cs typeface="Arial"/>
-                        </a:rPr>
-                        <a:t>Оба условия</a:t>
-                      </a:r>
-                    </a:p>
-                  </a:txBody>
-                  <a:tcPr marL="133350" marR="114300" marT="95250" marB="95250">
-                    <a:solidFill>
-                      <a:srgbClr val="FFFFFF"/>
-                    </a:solidFill>
-                  </a:tcPr>
-                </a:tc>
-                <a:tc>
-                  <a:txBody>
-                    <a:bodyPr/>
-                    <a:lstStyle/>
-                    <a:p>
-                      <a:r>
-                        <a:rPr sz="1725">
-                          <a:solidFill>
-                            <a:srgbClr val="232A25"/>
-                          </a:solidFill>
-                          <a:latin typeface="Arial"/>
-                          <a:ea typeface="Arial"/>
-                          <a:cs typeface="Arial"/>
-                        </a:rPr>
-                        <a:t>43</a:t>
-                      </a:r>
-                    </a:p>
-                  </a:txBody>
-                  <a:tcPr marL="133350" marR="114300" marT="95250" marB="95250">
-                    <a:solidFill>
-                      <a:srgbClr val="FFFFFF"/>
-                    </a:solidFill>
-                  </a:tcPr>
-                </a:tc>
-                <a:tc>
-                  <a:txBody>
-                    <a:bodyPr/>
-                    <a:lstStyle/>
-                    <a:p>
-                      <a:r>
-                        <a:rPr sz="1725">
-                          <a:solidFill>
-                            <a:srgbClr val="232A25"/>
-                          </a:solidFill>
-                          <a:latin typeface="Arial"/>
-                          <a:ea typeface="Arial"/>
-                          <a:cs typeface="Arial"/>
-                        </a:rPr>
-                        <a:t>66,1%</a:t>
-                      </a:r>
-                    </a:p>
-                  </a:txBody>
-                  <a:tcPr marL="133350" marR="114300" marT="95250" marB="95250">
-                    <a:solidFill>
-                      <a:srgbClr val="FFFFFF"/>
-                    </a:solidFill>
-                  </a:tcPr>
-                </a:tc>
-                <a:tc>
-                  <a:txBody>
-                    <a:bodyPr/>
-                    <a:lstStyle/>
-                    <a:p>
-                      <a:r>
-                        <a:rPr sz="1725">
-                          <a:solidFill>
-                            <a:srgbClr val="232A25"/>
-                          </a:solidFill>
-                          <a:latin typeface="Arial"/>
-                          <a:ea typeface="Arial"/>
-                          <a:cs typeface="Arial"/>
-                        </a:rPr>
-                        <a:t>24,4%</a:t>
+                        <a:t>15,9%</a:t>
                       </a:r>
                     </a:p>
                   </a:txBody>
@@ -5763,7 +5593,7 @@
           <p:cNvPr id="4" name="">
             <a:extLst xmlns:a="http://schemas.openxmlformats.org/drawingml/2006/main">
               <a:ext uri="{FF2B5EF4-FFF2-40B4-BE49-F238E27FC236}">
-                <a16:creationId xmlns:a16="http://schemas.microsoft.com/office/drawing/2014/main" id="{E1E6FAF4-52F5-457B-80C1-B455AA7CCB7D}"/>
+                <a16:creationId xmlns:a16="http://schemas.microsoft.com/office/drawing/2014/main" id="{7D170684-11AD-4590-9214-E5B4F97570F8}"/>
               </a:ext>
             </a:extLst>
           </p:cNvPr>
@@ -5774,8 +5604,8 @@
         </p:nvSpPr>
         <p:spPr>
           <a:xfrm xmlns:a="http://schemas.openxmlformats.org/drawingml/2006/main">
-            <a:off x="609600" y="5019675"/>
-            <a:ext cx="10858500" cy="933450"/>
+            <a:off x="609600" y="4972050"/>
+            <a:ext cx="10953750" cy="790575"/>
           </a:xfrm>
           <a:prstGeom xmlns:a="http://schemas.openxmlformats.org/drawingml/2006/main" prst="rect">
             <a:avLst/>
@@ -5792,48 +5622,105 @@
           <a:lstStyle xmlns:a="http://schemas.openxmlformats.org/drawingml/2006/main"/>
           <a:p xmlns:a="http://schemas.openxmlformats.org/drawingml/2006/main">
             <a:pPr>
-              <a:defRPr sz="2100" b="0">
-                <a:solidFill>
-                  <a:srgbClr val="232A25"/>
-                </a:solidFill>
-                <a:latin typeface="Arial"/>
-                <a:ea typeface="Arial"/>
-                <a:cs typeface="Arial"/>
-              </a:defRPr>
-            </a:pPr>
-            <a:r>
-              <a:rPr sz="2100" b="0">
-                <a:solidFill>
-                  <a:srgbClr val="232A25"/>
-                </a:solidFill>
-                <a:latin typeface="Arial"/>
-                <a:ea typeface="Arial"/>
-                <a:cs typeface="Arial"/>
-              </a:rPr>
-              <a:t>535 → 43 ошибочных переключения, но 66,1% решений отклонены.</a:t>
-            </a:r>
-          </a:p>
-          <a:p xmlns:a="http://schemas.openxmlformats.org/drawingml/2006/main">
-            <a:pPr>
-              <a:defRPr sz="2100" b="0">
-                <a:solidFill>
-                  <a:srgbClr val="232A25"/>
-                </a:solidFill>
-                <a:latin typeface="Arial"/>
-                <a:ea typeface="Arial"/>
-                <a:cs typeface="Arial"/>
-              </a:defRPr>
-            </a:pPr>
-            <a:r>
-              <a:rPr sz="2100" b="0">
-                <a:solidFill>
-                  <a:srgbClr val="232A25"/>
-                </a:solidFill>
-                <a:latin typeface="Arial"/>
-                <a:ea typeface="Arial"/>
-                <a:cs typeface="Arial"/>
-              </a:rPr>
-              <a:t>В двух из десяти движений правильная команда не появилась.</a:t>
+              <a:defRPr sz="2025" b="0">
+                <a:solidFill>
+                  <a:srgbClr val="232A25"/>
+                </a:solidFill>
+                <a:latin typeface="Arial"/>
+                <a:ea typeface="Arial"/>
+                <a:cs typeface="Arial"/>
+              </a:defRPr>
+            </a:pPr>
+            <a:r>
+              <a:rPr sz="2025" b="0">
+                <a:solidFill>
+                  <a:srgbClr val="232A25"/>
+                </a:solidFill>
+                <a:latin typeface="Arial"/>
+                <a:ea typeface="Arial"/>
+                <a:cs typeface="Arial"/>
+              </a:rPr>
+              <a:t>Режим выбирался при ≥70% принятых окон на валидации.</a:t>
+            </a:r>
+          </a:p>
+          <a:p xmlns:a="http://schemas.openxmlformats.org/drawingml/2006/main">
+            <a:pPr>
+              <a:defRPr sz="2025" b="0">
+                <a:solidFill>
+                  <a:srgbClr val="232A25"/>
+                </a:solidFill>
+                <a:latin typeface="Arial"/>
+                <a:ea typeface="Arial"/>
+                <a:cs typeface="Arial"/>
+              </a:defRPr>
+            </a:pPr>
+            <a:r>
+              <a:rPr sz="2025" b="0">
+                <a:solidFill>
+                  <a:srgbClr val="232A25"/>
+                </a:solidFill>
+                <a:latin typeface="Arial"/>
+                <a:ea typeface="Arial"/>
+                <a:cs typeface="Arial"/>
+              </a:rPr>
+              <a:t>На тесте S3 покрытие упало ниже этого ограничения.</a:t>
+            </a:r>
+          </a:p>
+        </p:txBody>
+      </p:sp>
+      <p:sp>
+        <p:nvSpPr>
+          <p:cNvPr id="5" name="">
+            <a:extLst xmlns:a="http://schemas.openxmlformats.org/drawingml/2006/main">
+              <a:ext uri="{FF2B5EF4-FFF2-40B4-BE49-F238E27FC236}">
+                <a16:creationId xmlns:a16="http://schemas.microsoft.com/office/drawing/2014/main" id="{86352727-A2ED-4365-8F02-C5548CC062BA}"/>
+              </a:ext>
+            </a:extLst>
+          </p:cNvPr>
+          <p:cNvSpPr>
+            <a:spLocks xmlns:a="http://schemas.openxmlformats.org/drawingml/2006/main" noGrp="1"/>
+          </p:cNvSpPr>
+          <p:nvPr/>
+        </p:nvSpPr>
+        <p:spPr>
+          <a:xfrm xmlns:a="http://schemas.openxmlformats.org/drawingml/2006/main">
+            <a:off x="609600" y="5991225"/>
+            <a:ext cx="10668000" cy="285750"/>
+          </a:xfrm>
+          <a:prstGeom xmlns:a="http://schemas.openxmlformats.org/drawingml/2006/main" prst="rect">
+            <a:avLst/>
+          </a:prstGeom>
+          <a:noFill xmlns:a="http://schemas.openxmlformats.org/drawingml/2006/main"/>
+          <a:ln xmlns:a="http://schemas.openxmlformats.org/drawingml/2006/main" w="0">
+            <a:noFill/>
+          </a:ln>
+        </p:spPr>
+        <p:txBody>
+          <a:bodyPr xmlns:a="http://schemas.openxmlformats.org/drawingml/2006/main">
+            <a:noAutofit/>
+          </a:bodyPr>
+          <a:lstStyle xmlns:a="http://schemas.openxmlformats.org/drawingml/2006/main"/>
+          <a:p xmlns:a="http://schemas.openxmlformats.org/drawingml/2006/main">
+            <a:pPr>
+              <a:defRPr sz="1575" b="0">
+                <a:solidFill>
+                  <a:srgbClr val="59635B"/>
+                </a:solidFill>
+                <a:latin typeface="Arial"/>
+                <a:ea typeface="Arial"/>
+                <a:cs typeface="Arial"/>
+              </a:defRPr>
+            </a:pPr>
+            <a:r>
+              <a:rPr sz="1575" b="0">
+                <a:solidFill>
+                  <a:srgbClr val="59635B"/>
+                </a:solidFill>
+                <a:latin typeface="Arial"/>
+                <a:ea typeface="Arial"/>
+                <a:cs typeface="Arial"/>
+              </a:rPr>
+              <a:t>Слабое место — распознавание покоя. Для настоящей кисти ошибок слишком много.</a:t>
             </a:r>
           </a:p>
         </p:txBody>
@@ -5841,7 +5728,7 @@
     </p:spTree>
     <p:extLst>
       <p:ext uri="{BB962C8B-B14F-4D97-AF65-F5344CB8AC3E}">
-        <p14:creationId xmlns:p14="http://schemas.microsoft.com/office/powerpoint/2010/main" val="830237843"/>
+        <p14:creationId xmlns:p14="http://schemas.microsoft.com/office/powerpoint/2010/main" val="1706226946"/>
       </p:ext>
     </p:extLst>
   </p:cSld>
@@ -5872,7 +5759,7 @@
           <p:cNvPr id="6" name="">
             <a:extLst xmlns:a="http://schemas.openxmlformats.org/drawingml/2006/main">
               <a:ext uri="{FF2B5EF4-FFF2-40B4-BE49-F238E27FC236}">
-                <a16:creationId xmlns:a16="http://schemas.microsoft.com/office/drawing/2014/main" id="{69F5B431-197A-483A-B139-0B2DDFADC6F0}"/>
+                <a16:creationId xmlns:a16="http://schemas.microsoft.com/office/drawing/2014/main" id="{31BD4130-D88B-439C-B4E5-2D134CC3E7C1}"/>
               </a:ext>
             </a:extLst>
           </p:cNvPr>
@@ -5919,7 +5806,7 @@
                 <a:ea typeface="Arial"/>
                 <a:cs typeface="Arial"/>
               </a:rPr>
-              <a:t>Требование 100 мс пока не достигнуто</a:t>
+              <a:t>Вычисления быстрые. Ответ пока нестабилен.</a:t>
             </a:r>
           </a:p>
         </p:txBody>
@@ -5929,7 +5816,7 @@
           <p:cNvPr id="2" name="">
             <a:extLst xmlns:a="http://schemas.openxmlformats.org/drawingml/2006/main">
               <a:ext uri="{FF2B5EF4-FFF2-40B4-BE49-F238E27FC236}">
-                <a16:creationId xmlns:a16="http://schemas.microsoft.com/office/drawing/2014/main" id="{C3983C44-9F36-4A10-9722-D5564B305B9E}"/>
+                <a16:creationId xmlns:a16="http://schemas.microsoft.com/office/drawing/2014/main" id="{919984DC-88A0-4CC3-945B-04DC916B51EF}"/>
               </a:ext>
             </a:extLst>
           </p:cNvPr>
@@ -5988,19 +5875,19 @@
           <p:nvPr/>
         </p:nvGraphicFramePr>
         <p:xfrm>
-          <a:off xmlns:a="http://schemas.openxmlformats.org/drawingml/2006/main" x="609600" y="1314450"/>
-          <a:ext xmlns:a="http://schemas.openxmlformats.org/drawingml/2006/main" cx="10953750" cy="3162300"/>
+          <a:off xmlns:a="http://schemas.openxmlformats.org/drawingml/2006/main" x="609600" y="1362075"/>
+          <a:ext xmlns:a="http://schemas.openxmlformats.org/drawingml/2006/main" cx="10953750" cy="2686050"/>
         </p:xfrm>
         <a:graphic xmlns:a="http://schemas.openxmlformats.org/drawingml/2006/main">
           <a:graphicData uri="http://schemas.openxmlformats.org/drawingml/2006/table">
             <a:tbl>
               <a:tblPr/>
               <a:tblGrid>
-                <a:gridCol w="5810250"/>
-                <a:gridCol w="2571750"/>
-                <a:gridCol w="2571750"/>
+                <a:gridCol w="6286500"/>
+                <a:gridCol w="2333625"/>
+                <a:gridCol w="2333625"/>
               </a:tblGrid>
-              <a:tr h="632460">
+              <a:tr h="671513">
                 <a:tc>
                   <a:txBody>
                     <a:bodyPr/>
@@ -6015,7 +5902,7 @@
                           <a:ea typeface="Arial"/>
                           <a:cs typeface="Arial"/>
                         </a:rPr>
-                        <a:t>Время первой правильной команды</a:t>
+                        <a:t>SVM после проверки</a:t>
                       </a:r>
                     </a:p>
                   </a:txBody>
@@ -6039,7 +5926,7 @@
                           <a:ea typeface="Arial"/>
                           <a:cs typeface="Arial"/>
                         </a:rPr>
-                        <a:t>Без проверки</a:t>
+                        <a:t>S2</a:t>
                       </a:r>
                     </a:p>
                   </a:txBody>
@@ -6063,7 +5950,7 @@
                           <a:ea typeface="Arial"/>
                           <a:cs typeface="Arial"/>
                         </a:rPr>
-                        <a:t>С проверкой</a:t>
+                        <a:t>S3</a:t>
                       </a:r>
                     </a:p>
                   </a:txBody>
@@ -6074,7 +5961,7 @@
                   </a:tcPr>
                 </a:tc>
               </a:tr>
-              <a:tr h="632460">
+              <a:tr h="671513">
                 <a:tc>
                   <a:txBody>
                     <a:bodyPr/>
@@ -6089,7 +5976,7 @@
                           <a:ea typeface="Arial"/>
                           <a:cs typeface="Arial"/>
                         </a:rPr>
-                        <a:t>Медиана</a:t>
+                        <a:t>Вычислительная итерация, p95</a:t>
                       </a:r>
                     </a:p>
                   </a:txBody>
@@ -6113,7 +6000,7 @@
                           <a:ea typeface="Arial"/>
                           <a:cs typeface="Arial"/>
                         </a:rPr>
-                        <a:t>175 мс</a:t>
+                        <a:t>1,16 мс</a:t>
                       </a:r>
                     </a:p>
                   </a:txBody>
@@ -6137,7 +6024,7 @@
                           <a:ea typeface="Arial"/>
                           <a:cs typeface="Arial"/>
                         </a:rPr>
-                        <a:t>225 мс</a:t>
+                        <a:t>1,29 мс</a:t>
                       </a:r>
                     </a:p>
                   </a:txBody>
@@ -6148,7 +6035,7 @@
                   </a:tcPr>
                 </a:tc>
               </a:tr>
-              <a:tr h="632460">
+              <a:tr h="671513">
                 <a:tc>
                   <a:txBody>
                     <a:bodyPr/>
@@ -6163,7 +6050,7 @@
                           <a:ea typeface="Arial"/>
                           <a:cs typeface="Arial"/>
                         </a:rPr>
-                        <a:t>95-й процентиль</a:t>
+                        <a:t>Первая правильная команда за 100 мс</a:t>
                       </a:r>
                     </a:p>
                   </a:txBody>
@@ -6187,7 +6074,7 @@
                           <a:ea typeface="Arial"/>
                           <a:cs typeface="Arial"/>
                         </a:rPr>
-                        <a:t>671 мс</a:t>
+                        <a:t>6 из 10</a:t>
                       </a:r>
                     </a:p>
                   </a:txBody>
@@ -6211,7 +6098,7 @@
                           <a:ea typeface="Arial"/>
                           <a:cs typeface="Arial"/>
                         </a:rPr>
-                        <a:t>846 мс</a:t>
+                        <a:t>6 из 10</a:t>
                       </a:r>
                     </a:p>
                   </a:txBody>
@@ -6222,7 +6109,7 @@
                   </a:tcPr>
                 </a:tc>
               </a:tr>
-              <a:tr h="632460">
+              <a:tr h="671513">
                 <a:tc>
                   <a:txBody>
                     <a:bodyPr/>
@@ -6237,7 +6124,7 @@
                           <a:ea typeface="Arial"/>
                           <a:cs typeface="Arial"/>
                         </a:rPr>
-                        <a:t>Правильный ответ за 100 мс</a:t>
+                        <a:t>Медиана устойчивого ответа</a:t>
                       </a:r>
                     </a:p>
                   </a:txBody>
@@ -6261,7 +6148,7 @@
                           <a:ea typeface="Arial"/>
                           <a:cs typeface="Arial"/>
                         </a:rPr>
-                        <a:t>4 из 10</a:t>
+                        <a:t>375 мс</a:t>
                       </a:r>
                     </a:p>
                   </a:txBody>
@@ -6285,81 +6172,7 @@
                           <a:ea typeface="Arial"/>
                           <a:cs typeface="Arial"/>
                         </a:rPr>
-                        <a:t>3 из 10</a:t>
-                      </a:r>
-                    </a:p>
-                  </a:txBody>
-                  <a:tcPr marL="133350" marR="114300" marT="95250" marB="95250">
-                    <a:solidFill>
-                      <a:srgbClr val="FFFFFF"/>
-                    </a:solidFill>
-                  </a:tcPr>
-                </a:tc>
-              </a:tr>
-              <a:tr h="632460">
-                <a:tc>
-                  <a:txBody>
-                    <a:bodyPr/>
-                    <a:lstStyle/>
-                    <a:p>
-                      <a:r>
-                        <a:rPr sz="1725">
-                          <a:solidFill>
-                            <a:srgbClr val="232A25"/>
-                          </a:solidFill>
-                          <a:latin typeface="Arial"/>
-                          <a:ea typeface="Arial"/>
-                          <a:cs typeface="Arial"/>
-                        </a:rPr>
-                        <a:t>Без правильной команды</a:t>
-                      </a:r>
-                    </a:p>
-                  </a:txBody>
-                  <a:tcPr marL="133350" marR="114300" marT="95250" marB="95250">
-                    <a:solidFill>
-                      <a:srgbClr val="FFFFFF"/>
-                    </a:solidFill>
-                  </a:tcPr>
-                </a:tc>
-                <a:tc>
-                  <a:txBody>
-                    <a:bodyPr/>
-                    <a:lstStyle/>
-                    <a:p>
-                      <a:r>
-                        <a:rPr sz="1725">
-                          <a:solidFill>
-                            <a:srgbClr val="232A25"/>
-                          </a:solidFill>
-                          <a:latin typeface="Arial"/>
-                          <a:ea typeface="Arial"/>
-                          <a:cs typeface="Arial"/>
-                        </a:rPr>
-                        <a:t>0 из 10</a:t>
-                      </a:r>
-                    </a:p>
-                  </a:txBody>
-                  <a:tcPr marL="133350" marR="114300" marT="95250" marB="95250">
-                    <a:solidFill>
-                      <a:srgbClr val="FFFFFF"/>
-                    </a:solidFill>
-                  </a:tcPr>
-                </a:tc>
-                <a:tc>
-                  <a:txBody>
-                    <a:bodyPr/>
-                    <a:lstStyle/>
-                    <a:p>
-                      <a:r>
-                        <a:rPr sz="1725">
-                          <a:solidFill>
-                            <a:srgbClr val="232A25"/>
-                          </a:solidFill>
-                          <a:latin typeface="Arial"/>
-                          <a:ea typeface="Arial"/>
-                          <a:cs typeface="Arial"/>
-                        </a:rPr>
-                        <a:t>2 из 10</a:t>
+                        <a:t>980 мс</a:t>
                       </a:r>
                     </a:p>
                   </a:txBody>
@@ -6379,7 +6192,7 @@
           <p:cNvPr id="4" name="">
             <a:extLst xmlns:a="http://schemas.openxmlformats.org/drawingml/2006/main">
               <a:ext uri="{FF2B5EF4-FFF2-40B4-BE49-F238E27FC236}">
-                <a16:creationId xmlns:a16="http://schemas.microsoft.com/office/drawing/2014/main" id="{0E4CFAF4-7AB0-4894-8CA3-A914D8CC74FE}"/>
+                <a16:creationId xmlns:a16="http://schemas.microsoft.com/office/drawing/2014/main" id="{82E2D330-2C9D-4601-A659-0E419D560E3C}"/>
               </a:ext>
             </a:extLst>
           </p:cNvPr>
@@ -6390,8 +6203,8 @@
         </p:nvSpPr>
         <p:spPr>
           <a:xfrm xmlns:a="http://schemas.openxmlformats.org/drawingml/2006/main">
-            <a:off x="609600" y="4857750"/>
-            <a:ext cx="10763250" cy="809625"/>
+            <a:off x="609600" y="4419600"/>
+            <a:ext cx="10953750" cy="857250"/>
           </a:xfrm>
           <a:prstGeom xmlns:a="http://schemas.openxmlformats.org/drawingml/2006/main" prst="rect">
             <a:avLst/>
@@ -6408,48 +6221,48 @@
           <a:lstStyle xmlns:a="http://schemas.openxmlformats.org/drawingml/2006/main"/>
           <a:p xmlns:a="http://schemas.openxmlformats.org/drawingml/2006/main">
             <a:pPr>
-              <a:defRPr sz="1950" b="0">
-                <a:solidFill>
-                  <a:srgbClr val="232A25"/>
-                </a:solidFill>
-                <a:latin typeface="Arial"/>
-                <a:ea typeface="Arial"/>
-                <a:cs typeface="Arial"/>
-              </a:defRPr>
-            </a:pPr>
-            <a:r>
-              <a:rPr sz="1950" b="0">
-                <a:solidFill>
-                  <a:srgbClr val="232A25"/>
-                </a:solidFill>
-                <a:latin typeface="Arial"/>
-                <a:ea typeface="Arial"/>
-                <a:cs typeface="Arial"/>
-              </a:rPr>
-              <a:t>Вычислительная итерация SVM: около 3,0 мс (95-й процентиль).</a:t>
-            </a:r>
-          </a:p>
-          <a:p xmlns:a="http://schemas.openxmlformats.org/drawingml/2006/main">
-            <a:pPr>
-              <a:defRPr sz="1950" b="0">
-                <a:solidFill>
-                  <a:srgbClr val="232A25"/>
-                </a:solidFill>
-                <a:latin typeface="Arial"/>
-                <a:ea typeface="Arial"/>
-                <a:cs typeface="Arial"/>
-              </a:defRPr>
-            </a:pPr>
-            <a:r>
-              <a:rPr sz="1950" b="0">
-                <a:solidFill>
-                  <a:srgbClr val="232A25"/>
-                </a:solidFill>
-                <a:latin typeface="Arial"/>
-                <a:ea typeface="Arial"/>
-                <a:cs typeface="Arial"/>
-              </a:rPr>
-              <a:t>Основная задержка здесь — ожидание правильного решения.</a:t>
+              <a:defRPr sz="2025" b="0">
+                <a:solidFill>
+                  <a:srgbClr val="232A25"/>
+                </a:solidFill>
+                <a:latin typeface="Arial"/>
+                <a:ea typeface="Arial"/>
+                <a:cs typeface="Arial"/>
+              </a:defRPr>
+            </a:pPr>
+            <a:r>
+              <a:rPr sz="2025" b="0">
+                <a:solidFill>
+                  <a:srgbClr val="232A25"/>
+                </a:solidFill>
+                <a:latin typeface="Arial"/>
+                <a:ea typeface="Arial"/>
+                <a:cs typeface="Arial"/>
+              </a:rPr>
+              <a:t>Устойчивый ответ: закончились 100 мс подряд правильных команд.</a:t>
+            </a:r>
+          </a:p>
+          <a:p xmlns:a="http://schemas.openxmlformats.org/drawingml/2006/main">
+            <a:pPr>
+              <a:defRPr sz="2025" b="0">
+                <a:solidFill>
+                  <a:srgbClr val="232A25"/>
+                </a:solidFill>
+                <a:latin typeface="Arial"/>
+                <a:ea typeface="Arial"/>
+                <a:cs typeface="Arial"/>
+              </a:defRPr>
+            </a:pPr>
+            <a:r>
+              <a:rPr sz="2025" b="0">
+                <a:solidFill>
+                  <a:srgbClr val="232A25"/>
+                </a:solidFill>
+                <a:latin typeface="Arial"/>
+                <a:ea typeface="Arial"/>
+                <a:cs typeface="Arial"/>
+              </a:rPr>
+              <a:t>Полная задержка до движения кисти не измерена.</a:t>
             </a:r>
           </a:p>
         </p:txBody>
@@ -6459,7 +6272,7 @@
           <p:cNvPr id="5" name="">
             <a:extLst xmlns:a="http://schemas.openxmlformats.org/drawingml/2006/main">
               <a:ext uri="{FF2B5EF4-FFF2-40B4-BE49-F238E27FC236}">
-                <a16:creationId xmlns:a16="http://schemas.microsoft.com/office/drawing/2014/main" id="{53825A07-2DCA-4F65-A724-E84F218F54BD}"/>
+                <a16:creationId xmlns:a16="http://schemas.microsoft.com/office/drawing/2014/main" id="{4636139B-D7AC-4AE7-B7EC-14B87F93E438}"/>
               </a:ext>
             </a:extLst>
           </p:cNvPr>
@@ -6470,8 +6283,8 @@
         </p:nvSpPr>
         <p:spPr>
           <a:xfrm xmlns:a="http://schemas.openxmlformats.org/drawingml/2006/main">
-            <a:off x="609600" y="5829300"/>
-            <a:ext cx="10572750" cy="523875"/>
+            <a:off x="609600" y="5591175"/>
+            <a:ext cx="10953750" cy="762000"/>
           </a:xfrm>
           <a:prstGeom xmlns:a="http://schemas.openxmlformats.org/drawingml/2006/main" prst="rect">
             <a:avLst/>
@@ -6488,7 +6301,7 @@
           <a:lstStyle xmlns:a="http://schemas.openxmlformats.org/drawingml/2006/main"/>
           <a:p xmlns:a="http://schemas.openxmlformats.org/drawingml/2006/main">
             <a:pPr>
-              <a:defRPr sz="1500" b="0">
+              <a:defRPr sz="1875" b="0">
                 <a:solidFill>
                   <a:srgbClr val="59635B"/>
                 </a:solidFill>
@@ -6498,7 +6311,7 @@
               </a:defRPr>
             </a:pPr>
             <a:r>
-              <a:rPr sz="1500" b="0">
+              <a:rPr sz="1875" b="0">
                 <a:solidFill>
                   <a:srgbClr val="59635B"/>
                 </a:solidFill>
@@ -6506,12 +6319,12 @@
                 <a:ea typeface="Arial"/>
                 <a:cs typeface="Arial"/>
               </a:rPr>
-              <a:t>Время отсчитано от метки записи. Связь и привод не измерялись.</a:t>
-            </a:r>
-          </a:p>
-          <a:p xmlns:a="http://schemas.openxmlformats.org/drawingml/2006/main">
-            <a:pPr>
-              <a:defRPr sz="1500" b="0">
+              <a:t>Для следующего стенда: проектный бюджет 92 мс + 8 мс резерва.</a:t>
+            </a:r>
+          </a:p>
+          <a:p xmlns:a="http://schemas.openxmlformats.org/drawingml/2006/main">
+            <a:pPr>
+              <a:defRPr sz="1875" b="0">
                 <a:solidFill>
                   <a:srgbClr val="59635B"/>
                 </a:solidFill>
@@ -6521,7 +6334,7 @@
               </a:defRPr>
             </a:pPr>
             <a:r>
-              <a:rPr sz="1500" b="0">
+              <a:rPr sz="1875" b="0">
                 <a:solidFill>
                   <a:srgbClr val="59635B"/>
                 </a:solidFill>
@@ -6529,7 +6342,7 @@
                 <a:ea typeface="Arial"/>
                 <a:cs typeface="Arial"/>
               </a:rPr>
-              <a:t>Медиана и процентиль приведены только для успешных движений.</a:t>
+              <a:t>Он требует нового варианта с окном 40 мс и проверки качества.</a:t>
             </a:r>
           </a:p>
         </p:txBody>
@@ -6537,7 +6350,7 @@
     </p:spTree>
     <p:extLst>
       <p:ext uri="{BB962C8B-B14F-4D97-AF65-F5344CB8AC3E}">
-        <p14:creationId xmlns:p14="http://schemas.microsoft.com/office/powerpoint/2010/main" val="81607411"/>
+        <p14:creationId xmlns:p14="http://schemas.microsoft.com/office/powerpoint/2010/main" val="18776460"/>
       </p:ext>
     </p:extLst>
   </p:cSld>
@@ -6568,7 +6381,7 @@
           <p:cNvPr id="6" name="">
             <a:extLst xmlns:a="http://schemas.openxmlformats.org/drawingml/2006/main">
               <a:ext uri="{FF2B5EF4-FFF2-40B4-BE49-F238E27FC236}">
-                <a16:creationId xmlns:a16="http://schemas.microsoft.com/office/drawing/2014/main" id="{C0261D29-DC48-42B7-AFE2-2FE2A148A6E5}"/>
+                <a16:creationId xmlns:a16="http://schemas.microsoft.com/office/drawing/2014/main" id="{FA8311E3-5642-4C1C-A5B0-47BC85413A30}"/>
               </a:ext>
             </a:extLst>
           </p:cNvPr>
@@ -6615,7 +6428,7 @@
                 <a:ea typeface="Arial"/>
                 <a:cs typeface="Arial"/>
               </a:rPr>
-              <a:t>Что проверять дальше</a:t>
+              <a:t>Что нужно для аппаратной версии</a:t>
             </a:r>
           </a:p>
         </p:txBody>
@@ -6625,7 +6438,7 @@
           <p:cNvPr id="2" name="">
             <a:extLst xmlns:a="http://schemas.openxmlformats.org/drawingml/2006/main">
               <a:ext uri="{FF2B5EF4-FFF2-40B4-BE49-F238E27FC236}">
-                <a16:creationId xmlns:a16="http://schemas.microsoft.com/office/drawing/2014/main" id="{D445CAEB-B1CC-46BF-A0A8-3E697D9C77CE}"/>
+                <a16:creationId xmlns:a16="http://schemas.microsoft.com/office/drawing/2014/main" id="{304D6F16-A3D1-40AA-A55E-838468A7D0CF}"/>
               </a:ext>
             </a:extLst>
           </p:cNvPr>
@@ -6682,7 +6495,7 @@
           <p:cNvPr id="3" name="">
             <a:extLst xmlns:a="http://schemas.openxmlformats.org/drawingml/2006/main">
               <a:ext uri="{FF2B5EF4-FFF2-40B4-BE49-F238E27FC236}">
-                <a16:creationId xmlns:a16="http://schemas.microsoft.com/office/drawing/2014/main" id="{0D4B5DF5-FD08-4EB1-9E58-C78C43F85D1C}"/>
+                <a16:creationId xmlns:a16="http://schemas.microsoft.com/office/drawing/2014/main" id="{7EAC7EA3-7AF1-404D-AFCB-B00EA9FEA80A}"/>
               </a:ext>
             </a:extLst>
           </p:cNvPr>
@@ -6693,8 +6506,8 @@
         </p:nvSpPr>
         <p:spPr>
           <a:xfrm xmlns:a="http://schemas.openxmlformats.org/drawingml/2006/main">
-            <a:off x="609600" y="1323975"/>
-            <a:ext cx="5429250" cy="3924300"/>
+            <a:off x="609600" y="1381125"/>
+            <a:ext cx="5524500" cy="3552825"/>
           </a:xfrm>
           <a:prstGeom xmlns:a="http://schemas.openxmlformats.org/drawingml/2006/main" prst="rect">
             <a:avLst/>
@@ -6729,7 +6542,7 @@
                 <a:ea typeface="Arial"/>
                 <a:cs typeface="Arial"/>
               </a:rPr>
-              <a:t>Сначала — новые записи и другие</a:t>
+              <a:t>Сначала: покой и короткие окна</a:t>
             </a:r>
           </a:p>
           <a:p xmlns:a="http://schemas.openxmlformats.org/drawingml/2006/main">
@@ -6752,7 +6565,12 @@
                 <a:ea typeface="Arial"/>
                 <a:cs typeface="Arial"/>
               </a:rPr>
-              <a:t>длины окон. Выбор параметров</a:t>
+              <a:t>на новом отложенном тесте.</a:t>
+            </a:r>
+          </a:p>
+          <a:p xmlns:a="http://schemas.openxmlformats.org/drawingml/2006/main">
+            <a:r>
+              <a:t/>
             </a:r>
           </a:p>
           <a:p xmlns:a="http://schemas.openxmlformats.org/drawingml/2006/main">
@@ -6775,7 +6593,30 @@
                 <a:ea typeface="Arial"/>
                 <a:cs typeface="Arial"/>
               </a:rPr>
-              <a:t>с ограничением числа отказов.</a:t>
+              <a:t>Затем: съём, калибровка, плата</a:t>
+            </a:r>
+          </a:p>
+          <a:p xmlns:a="http://schemas.openxmlformats.org/drawingml/2006/main">
+            <a:pPr>
+              <a:defRPr sz="2100" b="0">
+                <a:solidFill>
+                  <a:srgbClr val="232A25"/>
+                </a:solidFill>
+                <a:latin typeface="Arial"/>
+                <a:ea typeface="Arial"/>
+                <a:cs typeface="Arial"/>
+              </a:defRPr>
+            </a:pPr>
+            <a:r>
+              <a:rPr sz="2100" b="0">
+                <a:solidFill>
+                  <a:srgbClr val="232A25"/>
+                </a:solidFill>
+                <a:latin typeface="Arial"/>
+                <a:ea typeface="Arial"/>
+                <a:cs typeface="Arial"/>
+              </a:rPr>
+              <a:t>и проверка с приводом.</a:t>
             </a:r>
           </a:p>
           <a:p xmlns:a="http://schemas.openxmlformats.org/drawingml/2006/main">
@@ -6803,7 +6644,7 @@
                 <a:ea typeface="Arial"/>
                 <a:cs typeface="Arial"/>
               </a:rPr>
-              <a:t>Затем — персональная калибровка</a:t>
+              <a:t>План данных: 8–12 пользователей,</a:t>
             </a:r>
           </a:p>
           <a:p xmlns:a="http://schemas.openxmlformats.org/drawingml/2006/main">
@@ -6826,58 +6667,7 @@
                 <a:ea typeface="Arial"/>
                 <a:cs typeface="Arial"/>
               </a:rPr>
-              <a:t>и тест на другом визите.</a:t>
-            </a:r>
-          </a:p>
-          <a:p xmlns:a="http://schemas.openxmlformats.org/drawingml/2006/main">
-            <a:r>
-              <a:t/>
-            </a:r>
-          </a:p>
-          <a:p xmlns:a="http://schemas.openxmlformats.org/drawingml/2006/main">
-            <a:pPr>
-              <a:defRPr sz="2100" b="0">
-                <a:solidFill>
-                  <a:srgbClr val="232A25"/>
-                </a:solidFill>
-                <a:latin typeface="Arial"/>
-                <a:ea typeface="Arial"/>
-                <a:cs typeface="Arial"/>
-              </a:defRPr>
-            </a:pPr>
-            <a:r>
-              <a:rPr sz="2100" b="0">
-                <a:solidFill>
-                  <a:srgbClr val="232A25"/>
-                </a:solidFill>
-                <a:latin typeface="Arial"/>
-                <a:ea typeface="Arial"/>
-                <a:cs typeface="Arial"/>
-              </a:rPr>
-              <a:t>После этого — перенос на плату</a:t>
-            </a:r>
-          </a:p>
-          <a:p xmlns:a="http://schemas.openxmlformats.org/drawingml/2006/main">
-            <a:pPr>
-              <a:defRPr sz="2100" b="0">
-                <a:solidFill>
-                  <a:srgbClr val="232A25"/>
-                </a:solidFill>
-                <a:latin typeface="Arial"/>
-                <a:ea typeface="Arial"/>
-                <a:cs typeface="Arial"/>
-              </a:defRPr>
-            </a:pPr>
-            <a:r>
-              <a:rPr sz="2100" b="0">
-                <a:solidFill>
-                  <a:srgbClr val="232A25"/>
-                </a:solidFill>
-                <a:latin typeface="Arial"/>
-                <a:ea typeface="Arial"/>
-                <a:cs typeface="Arial"/>
-              </a:rPr>
-              <a:t>и измерение с настоящим приводом.</a:t>
+              <a:t>5 хватов × 10 повторов × 3 визита.</a:t>
             </a:r>
           </a:p>
         </p:txBody>
@@ -6889,8 +6679,8 @@
           <p:nvPr/>
         </p:nvGraphicFramePr>
         <p:xfrm>
-          <a:off xmlns:a="http://schemas.openxmlformats.org/drawingml/2006/main" x="6496050" y="1314450"/>
-          <a:ext xmlns:a="http://schemas.openxmlformats.org/drawingml/2006/main" cx="5067300" cy="3962400"/>
+          <a:off xmlns:a="http://schemas.openxmlformats.org/drawingml/2006/main" x="6496050" y="1343025"/>
+          <a:ext xmlns:a="http://schemas.openxmlformats.org/drawingml/2006/main" cx="5067300" cy="3895725"/>
         </p:xfrm>
         <a:graphic xmlns:a="http://schemas.openxmlformats.org/drawingml/2006/main">
           <a:graphicData uri="http://schemas.openxmlformats.org/drawingml/2006/table">
@@ -6900,7 +6690,7 @@
                 <a:gridCol w="3448050"/>
                 <a:gridCol w="1619250"/>
               </a:tblGrid>
-              <a:tr h="566057">
+              <a:tr h="556532">
                 <a:tc>
                   <a:txBody>
                     <a:bodyPr/>
@@ -6915,7 +6705,7 @@
                           <a:ea typeface="Arial"/>
                           <a:cs typeface="Arial"/>
                         </a:rPr>
-                        <a:t>Аппаратный стенд</a:t>
+                        <a:t>Стенд</a:t>
                       </a:r>
                     </a:p>
                   </a:txBody>
@@ -6939,7 +6729,7 @@
                           <a:ea typeface="Arial"/>
                           <a:cs typeface="Arial"/>
                         </a:rPr>
-                        <a:t>План, руб.</a:t>
+                        <a:t>Лимит, руб.</a:t>
                       </a:r>
                     </a:p>
                   </a:txBody>
@@ -6950,7 +6740,7 @@
                   </a:tcPr>
                 </a:tc>
               </a:tr>
-              <a:tr h="566057">
+              <a:tr h="556532">
                 <a:tc>
                   <a:txBody>
                     <a:bodyPr/>
@@ -7000,7 +6790,7 @@
                   </a:tcPr>
                 </a:tc>
               </a:tr>
-              <a:tr h="566057">
+              <a:tr h="556532">
                 <a:tc>
                   <a:txBody>
                     <a:bodyPr/>
@@ -7015,7 +6805,7 @@
                           <a:ea typeface="Arial"/>
                           <a:cs typeface="Arial"/>
                         </a:rPr>
-                        <a:t>Плата и интерфейсы</a:t>
+                        <a:t>STM32 и интерфейсы</a:t>
                       </a:r>
                     </a:p>
                   </a:txBody>
@@ -7050,7 +6840,7 @@
                   </a:tcPr>
                 </a:tc>
               </a:tr>
-              <a:tr h="566057">
+              <a:tr h="556532">
                 <a:tc>
                   <a:txBody>
                     <a:bodyPr/>
@@ -7100,7 +6890,7 @@
                   </a:tcPr>
                 </a:tc>
               </a:tr>
-              <a:tr h="566057">
+              <a:tr h="556532">
                 <a:tc>
                   <a:txBody>
                     <a:bodyPr/>
@@ -7150,7 +6940,7 @@
                   </a:tcPr>
                 </a:tc>
               </a:tr>
-              <a:tr h="566057">
+              <a:tr h="556532">
                 <a:tc>
                   <a:txBody>
                     <a:bodyPr/>
@@ -7200,7 +6990,7 @@
                   </a:tcPr>
                 </a:tc>
               </a:tr>
-              <a:tr h="566057">
+              <a:tr h="556532">
                 <a:tc>
                   <a:txBody>
                     <a:bodyPr/>
@@ -7259,7 +7049,7 @@
           <p:cNvPr id="5" name="">
             <a:extLst xmlns:a="http://schemas.openxmlformats.org/drawingml/2006/main">
               <a:ext uri="{FF2B5EF4-FFF2-40B4-BE49-F238E27FC236}">
-                <a16:creationId xmlns:a16="http://schemas.microsoft.com/office/drawing/2014/main" id="{4D2E5C5E-4186-4DED-8E0A-CBF02B689612}"/>
+                <a16:creationId xmlns:a16="http://schemas.microsoft.com/office/drawing/2014/main" id="{B6E8C1F5-51D2-448A-82F0-4B3149466678}"/>
               </a:ext>
             </a:extLst>
           </p:cNvPr>
@@ -7270,8 +7060,8 @@
         </p:nvSpPr>
         <p:spPr>
           <a:xfrm xmlns:a="http://schemas.openxmlformats.org/drawingml/2006/main">
-            <a:off x="609600" y="5753100"/>
-            <a:ext cx="10668000" cy="609600"/>
+            <a:off x="609600" y="5648325"/>
+            <a:ext cx="10858500" cy="809625"/>
           </a:xfrm>
           <a:prstGeom xmlns:a="http://schemas.openxmlformats.org/drawingml/2006/main" prst="rect">
             <a:avLst/>
@@ -7288,7 +7078,7 @@
           <a:lstStyle xmlns:a="http://schemas.openxmlformats.org/drawingml/2006/main"/>
           <a:p xmlns:a="http://schemas.openxmlformats.org/drawingml/2006/main">
             <a:pPr>
-              <a:defRPr sz="1650" b="0">
+              <a:defRPr sz="1875" b="0">
                 <a:solidFill>
                   <a:srgbClr val="59635B"/>
                 </a:solidFill>
@@ -7298,7 +7088,7 @@
               </a:defRPr>
             </a:pPr>
             <a:r>
-              <a:rPr sz="1650" b="0">
+              <a:rPr sz="1875" b="0">
                 <a:solidFill>
                   <a:srgbClr val="59635B"/>
                 </a:solidFill>
@@ -7306,12 +7096,12 @@
                 <a:ea typeface="Arial"/>
                 <a:cs typeface="Arial"/>
               </a:rPr>
-              <a:t>3–6 месяцев на аппаратную версию. Сумма — плановый бюджет,</a:t>
-            </a:r>
-          </a:p>
-          <a:p xmlns:a="http://schemas.openxmlformats.org/drawingml/2006/main">
-            <a:pPr>
-              <a:defRPr sz="1650" b="0">
+              <a:t>3–6 месяцев. Сумма — распределение бюджета, цены ещё проверяются.</a:t>
+            </a:r>
+          </a:p>
+          <a:p xmlns:a="http://schemas.openxmlformats.org/drawingml/2006/main">
+            <a:pPr>
+              <a:defRPr sz="1875" b="0">
                 <a:solidFill>
                   <a:srgbClr val="59635B"/>
                 </a:solidFill>
@@ -7321,7 +7111,7 @@
               </a:defRPr>
             </a:pPr>
             <a:r>
-              <a:rPr sz="1650" b="0">
+              <a:rPr sz="1875" b="0">
                 <a:solidFill>
                   <a:srgbClr val="59635B"/>
                 </a:solidFill>
@@ -7329,7 +7119,7 @@
                 <a:ea typeface="Arial"/>
                 <a:cs typeface="Arial"/>
               </a:rPr>
-              <a:t>без зарплаты и клинического исследования; цены требуют проверки.</a:t>
+              <a:t>В комплекте: код, журнал эксперимента и покадровое демо.</a:t>
             </a:r>
           </a:p>
         </p:txBody>
@@ -7337,7 +7127,7 @@
     </p:spTree>
     <p:extLst>
       <p:ext uri="{BB962C8B-B14F-4D97-AF65-F5344CB8AC3E}">
-        <p14:creationId xmlns:p14="http://schemas.microsoft.com/office/powerpoint/2010/main" val="2729323"/>
+        <p14:creationId xmlns:p14="http://schemas.microsoft.com/office/powerpoint/2010/main" val="159623642"/>
       </p:ext>
     </p:extLst>
   </p:cSld>

</xml_diff>

<commit_message>
Update repository presentation with recomputed numbers
@oai/artifact-tool is not available outside the original build
environment, so the slide text in docs/presentation.pptx is updated in
place with exactly the string changes made in build_presentation.mjs
(slides 5 and 6 and their notes). Only baseline accuracy and F1 come
from metrics.json, and they did not change. State on slide 6 that the
92 ms budget is a design target, not a demonstration.

Co-Authored-By: Claude Opus 5.5 <noreply@anthropic.com>
Claude-Session: https://claude.ai/code/session_01X5rv4P6NejbfbfU7vRNcth
</commit_message>
<xml_diff>
--- a/docs/presentation.pptx
+++ b/docs/presentation.pptx
@@ -728,7 +728,7 @@
           <a:lstStyle xmlns:a="http://schemas.openxmlformats.org/drawingml/2006/main"/>
           <a:p xmlns:a="http://schemas.openxmlformats.org/drawingml/2006/main">
             <a:r>
-              <a:t>Для S2 выбраны три подтверждения без порога. S3: threshold=0.5, margin=0.15, confirmations=2. Валидационное покрытие S3 70,96%, тестовое 67,84%. На обоих участниках получена правильная команда в каждом из десяти движений, но ранний правильный кадр не равен устойчивому управлению. Ошибочное переключение — смена принятого класса на неверный.</a:t>
+              <a:t>Для S2 выбраны три подтверждения без порога. S3: threshold=0.5, margin=0.15, confirmations=2. Валидационное покрытие S3 70,6%, тестовое 67,5%. Числа пересчитаны после исправления подтверждения (A, A, B, A, B больше не принимает последний B). На обоих участниках получена правильная команда в каждом из десяти движений, но ранний правильный кадр не равен устойчивому управлению. Ошибочное переключение — смена принятого класса на неверный.</a:t>
             </a:r>
           </a:p>
         </p:txBody>
@@ -798,7 +798,7 @@
           <a:lstStyle xmlns:a="http://schemas.openxmlformats.org/drawingml/2006/main"/>
           <a:p xmlns:a="http://schemas.openxmlformats.org/drawingml/2006/main">
             <a:r>
-              <a:t>Отсчёт по restimulus, не по независимому измерению сокращения. Нулевая медиана первого ответа S2 не является мгновенной физической реакцией. Сбор информативного участка 40 + шаг10 + задержка тракта5 + признаки1 + модель3 + подтверждение10 + связь3 + движение20 =92 мс. Это лимиты проектирования, не измеренные показатели. Выбранные окна 100/150 мс не подтверждают выполнение ТЗ. Подробнее: отчёт, страницы 5–6.</a:t>
+              <a:t>Отсчёт по restimulus, не по независимому измерению сокращения. Нулевая медиана первого ответа S2 не является мгновенной физической реакцией. Сбор информативного участка 40 + шаг10 + задержка тракта5 + признаки1 + модель3 + подтверждение10 + связь3 + движение20 =92 мс. Это лимиты проектирования, не измеренные показатели и не доказательство достижимости: бюджет предполагает, что окна 40 мс хватит, а эксперимент этого не показал. Вычисления измерены в облачной среде Linux; на Mac до исправления — 1,16 и 1,29 мс. Выбранные окна 100/150 мс не подтверждают выполнение ТЗ. Подробнее: отчёт, страницы 5–6.</a:t>
             </a:r>
           </a:p>
         </p:txBody>
@@ -5327,7 +5327,7 @@
                           <a:ea typeface="Arial"/>
                           <a:cs typeface="Arial"/>
                         </a:rPr>
-                        <a:t>482 → 178</a:t>
+                        <a:t>482 → 159</a:t>
                       </a:r>
                     </a:p>
                   </a:txBody>
@@ -5351,7 +5351,7 @@
                           <a:ea typeface="Arial"/>
                           <a:cs typeface="Arial"/>
                         </a:rPr>
-                        <a:t>546 → 175</a:t>
+                        <a:t>546 → 167</a:t>
                       </a:r>
                     </a:p>
                   </a:txBody>
@@ -5401,7 +5401,7 @@
                           <a:ea typeface="Arial"/>
                           <a:cs typeface="Arial"/>
                         </a:rPr>
-                        <a:t>86,5%</a:t>
+                        <a:t>85,0%</a:t>
                       </a:r>
                     </a:p>
                   </a:txBody>
@@ -5425,7 +5425,7 @@
                           <a:ea typeface="Arial"/>
                           <a:cs typeface="Arial"/>
                         </a:rPr>
-                        <a:t>67,8%</a:t>
+                        <a:t>67,5%</a:t>
                       </a:r>
                     </a:p>
                   </a:txBody>
@@ -5475,7 +5475,7 @@
                           <a:ea typeface="Arial"/>
                           <a:cs typeface="Arial"/>
                         </a:rPr>
-                        <a:t>29,3%</a:t>
+                        <a:t>28,8%</a:t>
                       </a:r>
                     </a:p>
                   </a:txBody>
@@ -5499,7 +5499,7 @@
                           <a:ea typeface="Arial"/>
                           <a:cs typeface="Arial"/>
                         </a:rPr>
-                        <a:t>32,0%</a:t>
+                        <a:t>31,9%</a:t>
                       </a:r>
                     </a:p>
                   </a:txBody>
@@ -5976,7 +5976,7 @@
                           <a:ea typeface="Arial"/>
                           <a:cs typeface="Arial"/>
                         </a:rPr>
-                        <a:t>Вычислительная итерация, p95</a:t>
+                        <a:t>Вычислительная итерация, p95 (облако)</a:t>
                       </a:r>
                     </a:p>
                   </a:txBody>
@@ -6000,7 +6000,7 @@
                           <a:ea typeface="Arial"/>
                           <a:cs typeface="Arial"/>
                         </a:rPr>
-                        <a:t>1,16 мс</a:t>
+                        <a:t>4,70 мс</a:t>
                       </a:r>
                     </a:p>
                   </a:txBody>
@@ -6024,7 +6024,7 @@
                           <a:ea typeface="Arial"/>
                           <a:cs typeface="Arial"/>
                         </a:rPr>
-                        <a:t>1,29 мс</a:t>
+                        <a:t>2,88 мс</a:t>
                       </a:r>
                     </a:p>
                   </a:txBody>
@@ -6148,7 +6148,7 @@
                           <a:ea typeface="Arial"/>
                           <a:cs typeface="Arial"/>
                         </a:rPr>
-                        <a:t>375 мс</a:t>
+                        <a:t>380 мс</a:t>
                       </a:r>
                     </a:p>
                   </a:txBody>
@@ -6342,7 +6342,7 @@
                 <a:ea typeface="Arial"/>
                 <a:cs typeface="Arial"/>
               </a:rPr>
-              <a:t>Он требует нового варианта с окном 40 мс и проверки качества.</a:t>
+              <a:t>Это цель, а не доказательство: окно 40 мс ещё не проверено.</a:t>
             </a:r>
           </a:p>
         </p:txBody>

</xml_diff>